<commit_message>
Clean up PowerPoint layout and finalize dashboard updates
</commit_message>
<xml_diff>
--- a/Cardamyst_Executive_Report.pptx
+++ b/Cardamyst_Executive_Report.pptx
@@ -16943,104 +16943,336 @@
           <a:p/>
         </p:txBody>
       </p:sp>
+      <p:graphicFrame>
+        <p:nvGraphicFramePr>
+          <p:cNvPr id="3" name="Table 2"/>
+          <p:cNvGraphicFramePr>
+            <a:graphicFrameLocks noGrp="1"/>
+          </p:cNvGraphicFramePr>
+          <p:nvPr/>
+        </p:nvGraphicFramePr>
+        <p:xfrm>
+          <a:off x="457200" y="1371600"/>
+          <a:ext cx="8229600" cy="1097280"/>
+        </p:xfrm>
+        <a:graphic>
+          <a:graphicData uri="http://schemas.openxmlformats.org/drawingml/2006/table">
+            <a:tbl>
+              <a:tblPr firstRow="1" bandRow="1">
+                <a:tableStyleId>{5C22544A-7EE6-4342-B048-85BDC9FD1C3A}</a:tableStyleId>
+              </a:tblPr>
+              <a:tblGrid>
+                <a:gridCol w="1645920"/>
+                <a:gridCol w="1645920"/>
+                <a:gridCol w="1645920"/>
+                <a:gridCol w="1645920"/>
+                <a:gridCol w="1645920"/>
+              </a:tblGrid>
+              <a:tr h="365760">
+                <a:tc>
+                  <a:txBody>
+                    <a:bodyPr/>
+                    <a:lstStyle/>
+                    <a:p>
+                      <a:pPr algn="ctr">
+                        <a:defRPr sz="1100" b="1">
+                          <a:solidFill>
+                            <a:srgbClr val="172852"/>
+                          </a:solidFill>
+                        </a:defRPr>
+                      </a:pPr>
+                      <a:r>
+                        <a:t>Total</a:t>
+                      </a:r>
+                    </a:p>
+                  </a:txBody>
+                  <a:tcPr/>
+                </a:tc>
+                <a:tc>
+                  <a:txBody>
+                    <a:bodyPr/>
+                    <a:lstStyle/>
+                    <a:p>
+                      <a:pPr algn="ctr">
+                        <a:defRPr sz="1100" b="1">
+                          <a:solidFill>
+                            <a:srgbClr val="172852"/>
+                          </a:solidFill>
+                        </a:defRPr>
+                      </a:pPr>
+                      <a:r>
+                        <a:t>Commercial</a:t>
+                      </a:r>
+                    </a:p>
+                  </a:txBody>
+                  <a:tcPr/>
+                </a:tc>
+                <a:tc>
+                  <a:txBody>
+                    <a:bodyPr/>
+                    <a:lstStyle/>
+                    <a:p>
+                      <a:pPr algn="ctr">
+                        <a:defRPr sz="1100" b="1">
+                          <a:solidFill>
+                            <a:srgbClr val="172852"/>
+                          </a:solidFill>
+                        </a:defRPr>
+                      </a:pPr>
+                      <a:r>
+                        <a:t>Medicare</a:t>
+                      </a:r>
+                    </a:p>
+                  </a:txBody>
+                  <a:tcPr/>
+                </a:tc>
+                <a:tc>
+                  <a:txBody>
+                    <a:bodyPr/>
+                    <a:lstStyle/>
+                    <a:p>
+                      <a:pPr algn="ctr">
+                        <a:defRPr sz="1100" b="1">
+                          <a:solidFill>
+                            <a:srgbClr val="172852"/>
+                          </a:solidFill>
+                        </a:defRPr>
+                      </a:pPr>
+                      <a:r>
+                        <a:t>Medicaid</a:t>
+                      </a:r>
+                    </a:p>
+                  </a:txBody>
+                  <a:tcPr/>
+                </a:tc>
+                <a:tc>
+                  <a:txBody>
+                    <a:bodyPr/>
+                    <a:lstStyle/>
+                    <a:p>
+                      <a:pPr algn="ctr">
+                        <a:defRPr sz="1100" b="1">
+                          <a:solidFill>
+                            <a:srgbClr val="172852"/>
+                          </a:solidFill>
+                        </a:defRPr>
+                      </a:pPr>
+                      <a:r>
+                        <a:t>Plans</a:t>
+                      </a:r>
+                    </a:p>
+                  </a:txBody>
+                  <a:tcPr/>
+                </a:tc>
+              </a:tr>
+              <a:tr h="365760">
+                <a:tc>
+                  <a:txBody>
+                    <a:bodyPr/>
+                    <a:lstStyle/>
+                    <a:p>
+                      <a:pPr algn="ctr">
+                        <a:defRPr sz="2400" b="1">
+                          <a:solidFill>
+                            <a:srgbClr val="0D7AB5"/>
+                          </a:solidFill>
+                        </a:defRPr>
+                      </a:pPr>
+                      <a:r>
+                        <a:t>3.7%</a:t>
+                      </a:r>
+                    </a:p>
+                  </a:txBody>
+                  <a:tcPr/>
+                </a:tc>
+                <a:tc>
+                  <a:txBody>
+                    <a:bodyPr/>
+                    <a:lstStyle/>
+                    <a:p>
+                      <a:pPr algn="ctr">
+                        <a:defRPr sz="2400" b="1">
+                          <a:solidFill>
+                            <a:srgbClr val="0D7AB5"/>
+                          </a:solidFill>
+                        </a:defRPr>
+                      </a:pPr>
+                      <a:r>
+                        <a:t>3.7%</a:t>
+                      </a:r>
+                    </a:p>
+                  </a:txBody>
+                  <a:tcPr/>
+                </a:tc>
+                <a:tc>
+                  <a:txBody>
+                    <a:bodyPr/>
+                    <a:lstStyle/>
+                    <a:p>
+                      <a:pPr algn="ctr">
+                        <a:defRPr sz="2400" b="1">
+                          <a:solidFill>
+                            <a:srgbClr val="0D7AB5"/>
+                          </a:solidFill>
+                        </a:defRPr>
+                      </a:pPr>
+                      <a:r>
+                        <a:t>0.0%</a:t>
+                      </a:r>
+                    </a:p>
+                  </a:txBody>
+                  <a:tcPr/>
+                </a:tc>
+                <a:tc>
+                  <a:txBody>
+                    <a:bodyPr/>
+                    <a:lstStyle/>
+                    <a:p>
+                      <a:pPr algn="ctr">
+                        <a:defRPr sz="2400" b="1">
+                          <a:solidFill>
+                            <a:srgbClr val="0D7AB5"/>
+                          </a:solidFill>
+                        </a:defRPr>
+                      </a:pPr>
+                      <a:r>
+                        <a:t>0.0%</a:t>
+                      </a:r>
+                    </a:p>
+                  </a:txBody>
+                  <a:tcPr/>
+                </a:tc>
+                <a:tc>
+                  <a:txBody>
+                    <a:bodyPr/>
+                    <a:lstStyle/>
+                    <a:p>
+                      <a:pPr algn="ctr">
+                        <a:defRPr sz="2400" b="1">
+                          <a:solidFill>
+                            <a:srgbClr val="0D7AB5"/>
+                          </a:solidFill>
+                        </a:defRPr>
+                      </a:pPr>
+                      <a:r>
+                        <a:t>31</a:t>
+                      </a:r>
+                    </a:p>
+                  </a:txBody>
+                  <a:tcPr/>
+                </a:tc>
+              </a:tr>
+              <a:tr h="365760">
+                <a:tc>
+                  <a:txBody>
+                    <a:bodyPr/>
+                    <a:lstStyle/>
+                    <a:p>
+                      <a:pPr algn="ctr">
+                        <a:defRPr sz="900" b="0">
+                          <a:solidFill>
+                            <a:srgbClr val="64748B"/>
+                          </a:solidFill>
+                        </a:defRPr>
+                      </a:pPr>
+                      <a:r>
+                        <a:t>186.6M lives</a:t>
+                      </a:r>
+                    </a:p>
+                  </a:txBody>
+                  <a:tcPr/>
+                </a:tc>
+                <a:tc>
+                  <a:txBody>
+                    <a:bodyPr/>
+                    <a:lstStyle/>
+                    <a:p>
+                      <a:pPr algn="ctr">
+                        <a:defRPr sz="900" b="0">
+                          <a:solidFill>
+                            <a:srgbClr val="64748B"/>
+                          </a:solidFill>
+                        </a:defRPr>
+                      </a:pPr>
+                      <a:r>
+                        <a:t>186.6M lives</a:t>
+                      </a:r>
+                    </a:p>
+                  </a:txBody>
+                  <a:tcPr/>
+                </a:tc>
+                <a:tc>
+                  <a:txBody>
+                    <a:bodyPr/>
+                    <a:lstStyle/>
+                    <a:p>
+                      <a:pPr algn="ctr">
+                        <a:defRPr sz="900" b="0">
+                          <a:solidFill>
+                            <a:srgbClr val="64748B"/>
+                          </a:solidFill>
+                        </a:defRPr>
+                      </a:pPr>
+                      <a:r>
+                        <a:t>51.0M lives</a:t>
+                      </a:r>
+                    </a:p>
+                  </a:txBody>
+                  <a:tcPr/>
+                </a:tc>
+                <a:tc>
+                  <a:txBody>
+                    <a:bodyPr/>
+                    <a:lstStyle/>
+                    <a:p>
+                      <a:pPr algn="ctr">
+                        <a:defRPr sz="900" b="0">
+                          <a:solidFill>
+                            <a:srgbClr val="64748B"/>
+                          </a:solidFill>
+                        </a:defRPr>
+                      </a:pPr>
+                      <a:r>
+                        <a:t>92.0M lives</a:t>
+                      </a:r>
+                    </a:p>
+                  </a:txBody>
+                  <a:tcPr/>
+                </a:tc>
+                <a:tc>
+                  <a:txBody>
+                    <a:bodyPr/>
+                    <a:lstStyle/>
+                    <a:p>
+                      <a:pPr algn="ctr">
+                        <a:defRPr sz="900" b="0">
+                          <a:solidFill>
+                            <a:srgbClr val="64748B"/>
+                          </a:solidFill>
+                        </a:defRPr>
+                      </a:pPr>
+                      <a:r>
+                        <a:t>With coverage</a:t>
+                      </a:r>
+                    </a:p>
+                  </a:txBody>
+                  <a:tcPr/>
+                </a:tc>
+              </a:tr>
+            </a:tbl>
+          </a:graphicData>
+        </a:graphic>
+      </p:graphicFrame>
       <p:sp>
         <p:nvSpPr>
-          <p:cNvPr id="3" name="Rounded Rectangle 2"/>
-          <p:cNvSpPr/>
-          <p:nvPr/>
-        </p:nvSpPr>
-        <p:spPr>
-          <a:xfrm>
-            <a:off x="457200" y="1645920"/>
-            <a:ext cx="1828800" cy="1097280"/>
-          </a:xfrm>
-          <a:prstGeom prst="roundRect">
-            <a:avLst/>
-          </a:prstGeom>
-          <a:solidFill>
-            <a:srgbClr val="FFFFFF"/>
-          </a:solidFill>
-          <a:ln>
-            <a:solidFill>
-              <a:srgbClr val="E2E8F0"/>
-            </a:solidFill>
-          </a:ln>
-        </p:spPr>
-        <p:style>
-          <a:lnRef idx="1">
-            <a:schemeClr val="accent1"/>
-          </a:lnRef>
-          <a:fillRef idx="3">
-            <a:schemeClr val="accent1"/>
-          </a:fillRef>
-          <a:effectRef idx="2">
-            <a:schemeClr val="accent1"/>
-          </a:effectRef>
-          <a:fontRef idx="minor">
-            <a:schemeClr val="lt1"/>
-          </a:fontRef>
-        </p:style>
-        <p:txBody>
-          <a:bodyPr rtlCol="0" anchor="ctr"/>
-          <a:lstStyle/>
-          <a:p>
-            <a:pPr algn="ctr"/>
-          </a:p>
-        </p:txBody>
-      </p:sp>
-      <p:sp>
-        <p:nvSpPr>
-          <p:cNvPr id="4" name="Rectangle 3"/>
-          <p:cNvSpPr/>
-          <p:nvPr/>
-        </p:nvSpPr>
-        <p:spPr>
-          <a:xfrm>
-            <a:off x="457200" y="2651760"/>
-            <a:ext cx="1828800" cy="91440"/>
-          </a:xfrm>
-          <a:prstGeom prst="rect">
-            <a:avLst/>
-          </a:prstGeom>
-          <a:solidFill>
-            <a:srgbClr val="00B2E3"/>
-          </a:solidFill>
-          <a:ln>
-            <a:noFill/>
-          </a:ln>
-        </p:spPr>
-        <p:style>
-          <a:lnRef idx="1">
-            <a:schemeClr val="accent1"/>
-          </a:lnRef>
-          <a:fillRef idx="3">
-            <a:schemeClr val="accent1"/>
-          </a:fillRef>
-          <a:effectRef idx="2">
-            <a:schemeClr val="accent1"/>
-          </a:effectRef>
-          <a:fontRef idx="minor">
-            <a:schemeClr val="lt1"/>
-          </a:fontRef>
-        </p:style>
-        <p:txBody>
-          <a:bodyPr rtlCol="0" anchor="ctr"/>
-          <a:lstStyle/>
-          <a:p>
-            <a:pPr algn="ctr"/>
-          </a:p>
-        </p:txBody>
-      </p:sp>
-      <p:sp>
-        <p:nvSpPr>
-          <p:cNvPr id="5" name="TextBox 4"/>
+          <p:cNvPr id="4" name="TextBox 3"/>
           <p:cNvSpPr txBox="1"/>
           <p:nvPr/>
         </p:nvSpPr>
         <p:spPr>
           <a:xfrm>
-            <a:off x="548640" y="1737360"/>
-            <a:ext cx="1645920" cy="274320"/>
+            <a:off x="457200" y="2743200"/>
+            <a:ext cx="3657600" cy="457200"/>
           </a:xfrm>
           <a:prstGeom prst="rect">
             <a:avLst/>
@@ -17048,889 +17280,12 @@
           <a:noFill/>
         </p:spPr>
         <p:txBody>
-          <a:bodyPr wrap="square">
+          <a:bodyPr wrap="none">
             <a:spAutoFit/>
           </a:bodyPr>
           <a:lstStyle/>
           <a:p>
-            <a:pPr algn="l">
-              <a:defRPr sz="1000" b="0">
-                <a:solidFill>
-                  <a:srgbClr val="54575E"/>
-                </a:solidFill>
-              </a:defRPr>
-            </a:pPr>
-            <a:r>
-              <a:t>Total Coverage</a:t>
-            </a:r>
-          </a:p>
-        </p:txBody>
-      </p:sp>
-      <p:sp>
-        <p:nvSpPr>
-          <p:cNvPr id="6" name="TextBox 5"/>
-          <p:cNvSpPr txBox="1"/>
-          <p:nvPr/>
-        </p:nvSpPr>
-        <p:spPr>
-          <a:xfrm>
-            <a:off x="548640" y="1965960"/>
-            <a:ext cx="1645920" cy="365760"/>
-          </a:xfrm>
-          <a:prstGeom prst="rect">
-            <a:avLst/>
-          </a:prstGeom>
-          <a:noFill/>
-        </p:spPr>
-        <p:txBody>
-          <a:bodyPr wrap="square">
-            <a:spAutoFit/>
-          </a:bodyPr>
-          <a:lstStyle/>
-          <a:p>
-            <a:pPr algn="l">
-              <a:defRPr sz="2400" b="1">
-                <a:solidFill>
-                  <a:srgbClr val="172852"/>
-                </a:solidFill>
-              </a:defRPr>
-            </a:pPr>
-            <a:r>
-              <a:t>3.7%</a:t>
-            </a:r>
-          </a:p>
-        </p:txBody>
-      </p:sp>
-      <p:sp>
-        <p:nvSpPr>
-          <p:cNvPr id="7" name="TextBox 6"/>
-          <p:cNvSpPr txBox="1"/>
-          <p:nvPr/>
-        </p:nvSpPr>
-        <p:spPr>
-          <a:xfrm>
-            <a:off x="548640" y="2377440"/>
-            <a:ext cx="1645920" cy="274320"/>
-          </a:xfrm>
-          <a:prstGeom prst="rect">
-            <a:avLst/>
-          </a:prstGeom>
-          <a:noFill/>
-        </p:spPr>
-        <p:txBody>
-          <a:bodyPr wrap="square">
-            <a:spAutoFit/>
-          </a:bodyPr>
-          <a:lstStyle/>
-          <a:p>
-            <a:pPr algn="l">
-              <a:defRPr sz="900" b="0">
-                <a:solidFill>
-                  <a:srgbClr val="54575E"/>
-                </a:solidFill>
-              </a:defRPr>
-            </a:pPr>
-            <a:r>
-              <a:t>of 186.6M lives</a:t>
-            </a:r>
-          </a:p>
-        </p:txBody>
-      </p:sp>
-      <p:sp>
-        <p:nvSpPr>
-          <p:cNvPr id="8" name="Rounded Rectangle 7"/>
-          <p:cNvSpPr/>
-          <p:nvPr/>
-        </p:nvSpPr>
-        <p:spPr>
-          <a:xfrm>
-            <a:off x="2560320" y="1645920"/>
-            <a:ext cx="1828800" cy="1097280"/>
-          </a:xfrm>
-          <a:prstGeom prst="roundRect">
-            <a:avLst/>
-          </a:prstGeom>
-          <a:solidFill>
-            <a:srgbClr val="FFFFFF"/>
-          </a:solidFill>
-          <a:ln>
-            <a:solidFill>
-              <a:srgbClr val="E2E8F0"/>
-            </a:solidFill>
-          </a:ln>
-        </p:spPr>
-        <p:style>
-          <a:lnRef idx="1">
-            <a:schemeClr val="accent1"/>
-          </a:lnRef>
-          <a:fillRef idx="3">
-            <a:schemeClr val="accent1"/>
-          </a:fillRef>
-          <a:effectRef idx="2">
-            <a:schemeClr val="accent1"/>
-          </a:effectRef>
-          <a:fontRef idx="minor">
-            <a:schemeClr val="lt1"/>
-          </a:fontRef>
-        </p:style>
-        <p:txBody>
-          <a:bodyPr rtlCol="0" anchor="ctr"/>
-          <a:lstStyle/>
-          <a:p>
-            <a:pPr algn="ctr"/>
-          </a:p>
-        </p:txBody>
-      </p:sp>
-      <p:sp>
-        <p:nvSpPr>
-          <p:cNvPr id="9" name="Rectangle 8"/>
-          <p:cNvSpPr/>
-          <p:nvPr/>
-        </p:nvSpPr>
-        <p:spPr>
-          <a:xfrm>
-            <a:off x="2560320" y="2651760"/>
-            <a:ext cx="1828800" cy="91440"/>
-          </a:xfrm>
-          <a:prstGeom prst="rect">
-            <a:avLst/>
-          </a:prstGeom>
-          <a:solidFill>
-            <a:srgbClr val="10B981"/>
-          </a:solidFill>
-          <a:ln>
-            <a:noFill/>
-          </a:ln>
-        </p:spPr>
-        <p:style>
-          <a:lnRef idx="1">
-            <a:schemeClr val="accent1"/>
-          </a:lnRef>
-          <a:fillRef idx="3">
-            <a:schemeClr val="accent1"/>
-          </a:fillRef>
-          <a:effectRef idx="2">
-            <a:schemeClr val="accent1"/>
-          </a:effectRef>
-          <a:fontRef idx="minor">
-            <a:schemeClr val="lt1"/>
-          </a:fontRef>
-        </p:style>
-        <p:txBody>
-          <a:bodyPr rtlCol="0" anchor="ctr"/>
-          <a:lstStyle/>
-          <a:p>
-            <a:pPr algn="ctr"/>
-          </a:p>
-        </p:txBody>
-      </p:sp>
-      <p:sp>
-        <p:nvSpPr>
-          <p:cNvPr id="10" name="TextBox 9"/>
-          <p:cNvSpPr txBox="1"/>
-          <p:nvPr/>
-        </p:nvSpPr>
-        <p:spPr>
-          <a:xfrm>
-            <a:off x="2651760" y="1737360"/>
-            <a:ext cx="1645920" cy="274320"/>
-          </a:xfrm>
-          <a:prstGeom prst="rect">
-            <a:avLst/>
-          </a:prstGeom>
-          <a:noFill/>
-        </p:spPr>
-        <p:txBody>
-          <a:bodyPr wrap="square">
-            <a:spAutoFit/>
-          </a:bodyPr>
-          <a:lstStyle/>
-          <a:p>
-            <a:pPr algn="l">
-              <a:defRPr sz="1000" b="0">
-                <a:solidFill>
-                  <a:srgbClr val="54575E"/>
-                </a:solidFill>
-              </a:defRPr>
-            </a:pPr>
-            <a:r>
-              <a:t>Commercial</a:t>
-            </a:r>
-          </a:p>
-        </p:txBody>
-      </p:sp>
-      <p:sp>
-        <p:nvSpPr>
-          <p:cNvPr id="11" name="TextBox 10"/>
-          <p:cNvSpPr txBox="1"/>
-          <p:nvPr/>
-        </p:nvSpPr>
-        <p:spPr>
-          <a:xfrm>
-            <a:off x="2651760" y="1965960"/>
-            <a:ext cx="1645920" cy="365760"/>
-          </a:xfrm>
-          <a:prstGeom prst="rect">
-            <a:avLst/>
-          </a:prstGeom>
-          <a:noFill/>
-        </p:spPr>
-        <p:txBody>
-          <a:bodyPr wrap="square">
-            <a:spAutoFit/>
-          </a:bodyPr>
-          <a:lstStyle/>
-          <a:p>
-            <a:pPr algn="l">
-              <a:defRPr sz="2400" b="1">
-                <a:solidFill>
-                  <a:srgbClr val="172852"/>
-                </a:solidFill>
-              </a:defRPr>
-            </a:pPr>
-            <a:r>
-              <a:t>3.7%</a:t>
-            </a:r>
-          </a:p>
-        </p:txBody>
-      </p:sp>
-      <p:sp>
-        <p:nvSpPr>
-          <p:cNvPr id="12" name="TextBox 11"/>
-          <p:cNvSpPr txBox="1"/>
-          <p:nvPr/>
-        </p:nvSpPr>
-        <p:spPr>
-          <a:xfrm>
-            <a:off x="2651760" y="2377440"/>
-            <a:ext cx="1645920" cy="274320"/>
-          </a:xfrm>
-          <a:prstGeom prst="rect">
-            <a:avLst/>
-          </a:prstGeom>
-          <a:noFill/>
-        </p:spPr>
-        <p:txBody>
-          <a:bodyPr wrap="square">
-            <a:spAutoFit/>
-          </a:bodyPr>
-          <a:lstStyle/>
-          <a:p>
-            <a:pPr algn="l">
-              <a:defRPr sz="900" b="0">
-                <a:solidFill>
-                  <a:srgbClr val="54575E"/>
-                </a:solidFill>
-              </a:defRPr>
-            </a:pPr>
-            <a:r>
-              <a:t>of 186.6M lives</a:t>
-            </a:r>
-          </a:p>
-        </p:txBody>
-      </p:sp>
-      <p:sp>
-        <p:nvSpPr>
-          <p:cNvPr id="13" name="Rounded Rectangle 12"/>
-          <p:cNvSpPr/>
-          <p:nvPr/>
-        </p:nvSpPr>
-        <p:spPr>
-          <a:xfrm>
-            <a:off x="4663440" y="1645920"/>
-            <a:ext cx="1828800" cy="1097280"/>
-          </a:xfrm>
-          <a:prstGeom prst="roundRect">
-            <a:avLst/>
-          </a:prstGeom>
-          <a:solidFill>
-            <a:srgbClr val="FFFFFF"/>
-          </a:solidFill>
-          <a:ln>
-            <a:solidFill>
-              <a:srgbClr val="E2E8F0"/>
-            </a:solidFill>
-          </a:ln>
-        </p:spPr>
-        <p:style>
-          <a:lnRef idx="1">
-            <a:schemeClr val="accent1"/>
-          </a:lnRef>
-          <a:fillRef idx="3">
-            <a:schemeClr val="accent1"/>
-          </a:fillRef>
-          <a:effectRef idx="2">
-            <a:schemeClr val="accent1"/>
-          </a:effectRef>
-          <a:fontRef idx="minor">
-            <a:schemeClr val="lt1"/>
-          </a:fontRef>
-        </p:style>
-        <p:txBody>
-          <a:bodyPr rtlCol="0" anchor="ctr"/>
-          <a:lstStyle/>
-          <a:p>
-            <a:pPr algn="ctr"/>
-          </a:p>
-        </p:txBody>
-      </p:sp>
-      <p:sp>
-        <p:nvSpPr>
-          <p:cNvPr id="14" name="Rectangle 13"/>
-          <p:cNvSpPr/>
-          <p:nvPr/>
-        </p:nvSpPr>
-        <p:spPr>
-          <a:xfrm>
-            <a:off x="4663440" y="2651760"/>
-            <a:ext cx="1828800" cy="91440"/>
-          </a:xfrm>
-          <a:prstGeom prst="rect">
-            <a:avLst/>
-          </a:prstGeom>
-          <a:solidFill>
-            <a:srgbClr val="0D7AB5"/>
-          </a:solidFill>
-          <a:ln>
-            <a:noFill/>
-          </a:ln>
-        </p:spPr>
-        <p:style>
-          <a:lnRef idx="1">
-            <a:schemeClr val="accent1"/>
-          </a:lnRef>
-          <a:fillRef idx="3">
-            <a:schemeClr val="accent1"/>
-          </a:fillRef>
-          <a:effectRef idx="2">
-            <a:schemeClr val="accent1"/>
-          </a:effectRef>
-          <a:fontRef idx="minor">
-            <a:schemeClr val="lt1"/>
-          </a:fontRef>
-        </p:style>
-        <p:txBody>
-          <a:bodyPr rtlCol="0" anchor="ctr"/>
-          <a:lstStyle/>
-          <a:p>
-            <a:pPr algn="ctr"/>
-          </a:p>
-        </p:txBody>
-      </p:sp>
-      <p:sp>
-        <p:nvSpPr>
-          <p:cNvPr id="15" name="TextBox 14"/>
-          <p:cNvSpPr txBox="1"/>
-          <p:nvPr/>
-        </p:nvSpPr>
-        <p:spPr>
-          <a:xfrm>
-            <a:off x="4754879" y="1737360"/>
-            <a:ext cx="1645920" cy="274320"/>
-          </a:xfrm>
-          <a:prstGeom prst="rect">
-            <a:avLst/>
-          </a:prstGeom>
-          <a:noFill/>
-        </p:spPr>
-        <p:txBody>
-          <a:bodyPr wrap="square">
-            <a:spAutoFit/>
-          </a:bodyPr>
-          <a:lstStyle/>
-          <a:p>
-            <a:pPr algn="l">
-              <a:defRPr sz="1000" b="0">
-                <a:solidFill>
-                  <a:srgbClr val="54575E"/>
-                </a:solidFill>
-              </a:defRPr>
-            </a:pPr>
-            <a:r>
-              <a:t>Medicare</a:t>
-            </a:r>
-          </a:p>
-        </p:txBody>
-      </p:sp>
-      <p:sp>
-        <p:nvSpPr>
-          <p:cNvPr id="16" name="TextBox 15"/>
-          <p:cNvSpPr txBox="1"/>
-          <p:nvPr/>
-        </p:nvSpPr>
-        <p:spPr>
-          <a:xfrm>
-            <a:off x="4754879" y="1965960"/>
-            <a:ext cx="1645920" cy="365760"/>
-          </a:xfrm>
-          <a:prstGeom prst="rect">
-            <a:avLst/>
-          </a:prstGeom>
-          <a:noFill/>
-        </p:spPr>
-        <p:txBody>
-          <a:bodyPr wrap="square">
-            <a:spAutoFit/>
-          </a:bodyPr>
-          <a:lstStyle/>
-          <a:p>
-            <a:pPr algn="l">
-              <a:defRPr sz="2400" b="1">
-                <a:solidFill>
-                  <a:srgbClr val="172852"/>
-                </a:solidFill>
-              </a:defRPr>
-            </a:pPr>
-            <a:r>
-              <a:t>0.0%</a:t>
-            </a:r>
-          </a:p>
-        </p:txBody>
-      </p:sp>
-      <p:sp>
-        <p:nvSpPr>
-          <p:cNvPr id="17" name="TextBox 16"/>
-          <p:cNvSpPr txBox="1"/>
-          <p:nvPr/>
-        </p:nvSpPr>
-        <p:spPr>
-          <a:xfrm>
-            <a:off x="4754879" y="2377440"/>
-            <a:ext cx="1645920" cy="274320"/>
-          </a:xfrm>
-          <a:prstGeom prst="rect">
-            <a:avLst/>
-          </a:prstGeom>
-          <a:noFill/>
-        </p:spPr>
-        <p:txBody>
-          <a:bodyPr wrap="square">
-            <a:spAutoFit/>
-          </a:bodyPr>
-          <a:lstStyle/>
-          <a:p>
-            <a:pPr algn="l">
-              <a:defRPr sz="900" b="0">
-                <a:solidFill>
-                  <a:srgbClr val="54575E"/>
-                </a:solidFill>
-              </a:defRPr>
-            </a:pPr>
-            <a:r>
-              <a:t>of 51.0M lives</a:t>
-            </a:r>
-          </a:p>
-        </p:txBody>
-      </p:sp>
-      <p:sp>
-        <p:nvSpPr>
-          <p:cNvPr id="18" name="Rounded Rectangle 17"/>
-          <p:cNvSpPr/>
-          <p:nvPr/>
-        </p:nvSpPr>
-        <p:spPr>
-          <a:xfrm>
-            <a:off x="6766559" y="1645920"/>
-            <a:ext cx="1828800" cy="1097280"/>
-          </a:xfrm>
-          <a:prstGeom prst="roundRect">
-            <a:avLst/>
-          </a:prstGeom>
-          <a:solidFill>
-            <a:srgbClr val="FFFFFF"/>
-          </a:solidFill>
-          <a:ln>
-            <a:solidFill>
-              <a:srgbClr val="E2E8F0"/>
-            </a:solidFill>
-          </a:ln>
-        </p:spPr>
-        <p:style>
-          <a:lnRef idx="1">
-            <a:schemeClr val="accent1"/>
-          </a:lnRef>
-          <a:fillRef idx="3">
-            <a:schemeClr val="accent1"/>
-          </a:fillRef>
-          <a:effectRef idx="2">
-            <a:schemeClr val="accent1"/>
-          </a:effectRef>
-          <a:fontRef idx="minor">
-            <a:schemeClr val="lt1"/>
-          </a:fontRef>
-        </p:style>
-        <p:txBody>
-          <a:bodyPr rtlCol="0" anchor="ctr"/>
-          <a:lstStyle/>
-          <a:p>
-            <a:pPr algn="ctr"/>
-          </a:p>
-        </p:txBody>
-      </p:sp>
-      <p:sp>
-        <p:nvSpPr>
-          <p:cNvPr id="19" name="Rectangle 18"/>
-          <p:cNvSpPr/>
-          <p:nvPr/>
-        </p:nvSpPr>
-        <p:spPr>
-          <a:xfrm>
-            <a:off x="6766559" y="2651760"/>
-            <a:ext cx="1828800" cy="91440"/>
-          </a:xfrm>
-          <a:prstGeom prst="rect">
-            <a:avLst/>
-          </a:prstGeom>
-          <a:solidFill>
-            <a:srgbClr val="E31D93"/>
-          </a:solidFill>
-          <a:ln>
-            <a:noFill/>
-          </a:ln>
-        </p:spPr>
-        <p:style>
-          <a:lnRef idx="1">
-            <a:schemeClr val="accent1"/>
-          </a:lnRef>
-          <a:fillRef idx="3">
-            <a:schemeClr val="accent1"/>
-          </a:fillRef>
-          <a:effectRef idx="2">
-            <a:schemeClr val="accent1"/>
-          </a:effectRef>
-          <a:fontRef idx="minor">
-            <a:schemeClr val="lt1"/>
-          </a:fontRef>
-        </p:style>
-        <p:txBody>
-          <a:bodyPr rtlCol="0" anchor="ctr"/>
-          <a:lstStyle/>
-          <a:p>
-            <a:pPr algn="ctr"/>
-          </a:p>
-        </p:txBody>
-      </p:sp>
-      <p:sp>
-        <p:nvSpPr>
-          <p:cNvPr id="20" name="TextBox 19"/>
-          <p:cNvSpPr txBox="1"/>
-          <p:nvPr/>
-        </p:nvSpPr>
-        <p:spPr>
-          <a:xfrm>
-            <a:off x="6857999" y="1737360"/>
-            <a:ext cx="1645920" cy="274320"/>
-          </a:xfrm>
-          <a:prstGeom prst="rect">
-            <a:avLst/>
-          </a:prstGeom>
-          <a:noFill/>
-        </p:spPr>
-        <p:txBody>
-          <a:bodyPr wrap="square">
-            <a:spAutoFit/>
-          </a:bodyPr>
-          <a:lstStyle/>
-          <a:p>
-            <a:pPr algn="l">
-              <a:defRPr sz="1000" b="0">
-                <a:solidFill>
-                  <a:srgbClr val="54575E"/>
-                </a:solidFill>
-              </a:defRPr>
-            </a:pPr>
-            <a:r>
-              <a:t>Medicaid</a:t>
-            </a:r>
-          </a:p>
-        </p:txBody>
-      </p:sp>
-      <p:sp>
-        <p:nvSpPr>
-          <p:cNvPr id="21" name="TextBox 20"/>
-          <p:cNvSpPr txBox="1"/>
-          <p:nvPr/>
-        </p:nvSpPr>
-        <p:spPr>
-          <a:xfrm>
-            <a:off x="6857999" y="1965960"/>
-            <a:ext cx="1645920" cy="365760"/>
-          </a:xfrm>
-          <a:prstGeom prst="rect">
-            <a:avLst/>
-          </a:prstGeom>
-          <a:noFill/>
-        </p:spPr>
-        <p:txBody>
-          <a:bodyPr wrap="square">
-            <a:spAutoFit/>
-          </a:bodyPr>
-          <a:lstStyle/>
-          <a:p>
-            <a:pPr algn="l">
-              <a:defRPr sz="2400" b="1">
-                <a:solidFill>
-                  <a:srgbClr val="172852"/>
-                </a:solidFill>
-              </a:defRPr>
-            </a:pPr>
-            <a:r>
-              <a:t>0.0%</a:t>
-            </a:r>
-          </a:p>
-        </p:txBody>
-      </p:sp>
-      <p:sp>
-        <p:nvSpPr>
-          <p:cNvPr id="22" name="TextBox 21"/>
-          <p:cNvSpPr txBox="1"/>
-          <p:nvPr/>
-        </p:nvSpPr>
-        <p:spPr>
-          <a:xfrm>
-            <a:off x="6857999" y="2377440"/>
-            <a:ext cx="1645920" cy="274320"/>
-          </a:xfrm>
-          <a:prstGeom prst="rect">
-            <a:avLst/>
-          </a:prstGeom>
-          <a:noFill/>
-        </p:spPr>
-        <p:txBody>
-          <a:bodyPr wrap="square">
-            <a:spAutoFit/>
-          </a:bodyPr>
-          <a:lstStyle/>
-          <a:p>
-            <a:pPr algn="l">
-              <a:defRPr sz="900" b="0">
-                <a:solidFill>
-                  <a:srgbClr val="54575E"/>
-                </a:solidFill>
-              </a:defRPr>
-            </a:pPr>
-            <a:r>
-              <a:t>of 92.0M lives</a:t>
-            </a:r>
-          </a:p>
-        </p:txBody>
-      </p:sp>
-      <p:sp>
-        <p:nvSpPr>
-          <p:cNvPr id="23" name="Rounded Rectangle 22"/>
-          <p:cNvSpPr/>
-          <p:nvPr/>
-        </p:nvSpPr>
-        <p:spPr>
-          <a:xfrm>
-            <a:off x="8869680" y="1645920"/>
-            <a:ext cx="1828800" cy="1097280"/>
-          </a:xfrm>
-          <a:prstGeom prst="roundRect">
-            <a:avLst/>
-          </a:prstGeom>
-          <a:solidFill>
-            <a:srgbClr val="FFFFFF"/>
-          </a:solidFill>
-          <a:ln>
-            <a:solidFill>
-              <a:srgbClr val="E2E8F0"/>
-            </a:solidFill>
-          </a:ln>
-        </p:spPr>
-        <p:style>
-          <a:lnRef idx="1">
-            <a:schemeClr val="accent1"/>
-          </a:lnRef>
-          <a:fillRef idx="3">
-            <a:schemeClr val="accent1"/>
-          </a:fillRef>
-          <a:effectRef idx="2">
-            <a:schemeClr val="accent1"/>
-          </a:effectRef>
-          <a:fontRef idx="minor">
-            <a:schemeClr val="lt1"/>
-          </a:fontRef>
-        </p:style>
-        <p:txBody>
-          <a:bodyPr rtlCol="0" anchor="ctr"/>
-          <a:lstStyle/>
-          <a:p>
-            <a:pPr algn="ctr"/>
-          </a:p>
-        </p:txBody>
-      </p:sp>
-      <p:sp>
-        <p:nvSpPr>
-          <p:cNvPr id="24" name="Rectangle 23"/>
-          <p:cNvSpPr/>
-          <p:nvPr/>
-        </p:nvSpPr>
-        <p:spPr>
-          <a:xfrm>
-            <a:off x="8869680" y="2651760"/>
-            <a:ext cx="1828800" cy="91440"/>
-          </a:xfrm>
-          <a:prstGeom prst="rect">
-            <a:avLst/>
-          </a:prstGeom>
-          <a:solidFill>
-            <a:srgbClr val="00B2E3"/>
-          </a:solidFill>
-          <a:ln>
-            <a:noFill/>
-          </a:ln>
-        </p:spPr>
-        <p:style>
-          <a:lnRef idx="1">
-            <a:schemeClr val="accent1"/>
-          </a:lnRef>
-          <a:fillRef idx="3">
-            <a:schemeClr val="accent1"/>
-          </a:fillRef>
-          <a:effectRef idx="2">
-            <a:schemeClr val="accent1"/>
-          </a:effectRef>
-          <a:fontRef idx="minor">
-            <a:schemeClr val="lt1"/>
-          </a:fontRef>
-        </p:style>
-        <p:txBody>
-          <a:bodyPr rtlCol="0" anchor="ctr"/>
-          <a:lstStyle/>
-          <a:p>
-            <a:pPr algn="ctr"/>
-          </a:p>
-        </p:txBody>
-      </p:sp>
-      <p:sp>
-        <p:nvSpPr>
-          <p:cNvPr id="25" name="TextBox 24"/>
-          <p:cNvSpPr txBox="1"/>
-          <p:nvPr/>
-        </p:nvSpPr>
-        <p:spPr>
-          <a:xfrm>
-            <a:off x="8961119" y="1737360"/>
-            <a:ext cx="1645920" cy="274320"/>
-          </a:xfrm>
-          <a:prstGeom prst="rect">
-            <a:avLst/>
-          </a:prstGeom>
-          <a:noFill/>
-        </p:spPr>
-        <p:txBody>
-          <a:bodyPr wrap="square">
-            <a:spAutoFit/>
-          </a:bodyPr>
-          <a:lstStyle/>
-          <a:p>
-            <a:pPr algn="l">
-              <a:defRPr sz="1000" b="0">
-                <a:solidFill>
-                  <a:srgbClr val="54575E"/>
-                </a:solidFill>
-              </a:defRPr>
-            </a:pPr>
-            <a:r>
-              <a:t>Plans</a:t>
-            </a:r>
-          </a:p>
-        </p:txBody>
-      </p:sp>
-      <p:sp>
-        <p:nvSpPr>
-          <p:cNvPr id="26" name="TextBox 25"/>
-          <p:cNvSpPr txBox="1"/>
-          <p:nvPr/>
-        </p:nvSpPr>
-        <p:spPr>
-          <a:xfrm>
-            <a:off x="8961119" y="1965960"/>
-            <a:ext cx="1645920" cy="365760"/>
-          </a:xfrm>
-          <a:prstGeom prst="rect">
-            <a:avLst/>
-          </a:prstGeom>
-          <a:noFill/>
-        </p:spPr>
-        <p:txBody>
-          <a:bodyPr wrap="square">
-            <a:spAutoFit/>
-          </a:bodyPr>
-          <a:lstStyle/>
-          <a:p>
-            <a:pPr algn="l">
-              <a:defRPr sz="2400" b="1">
-                <a:solidFill>
-                  <a:srgbClr val="172852"/>
-                </a:solidFill>
-              </a:defRPr>
-            </a:pPr>
-            <a:r>
-              <a:t>31</a:t>
-            </a:r>
-          </a:p>
-        </p:txBody>
-      </p:sp>
-      <p:sp>
-        <p:nvSpPr>
-          <p:cNvPr id="27" name="TextBox 26"/>
-          <p:cNvSpPr txBox="1"/>
-          <p:nvPr/>
-        </p:nvSpPr>
-        <p:spPr>
-          <a:xfrm>
-            <a:off x="8961119" y="2377440"/>
-            <a:ext cx="1645920" cy="274320"/>
-          </a:xfrm>
-          <a:prstGeom prst="rect">
-            <a:avLst/>
-          </a:prstGeom>
-          <a:noFill/>
-        </p:spPr>
-        <p:txBody>
-          <a:bodyPr wrap="square">
-            <a:spAutoFit/>
-          </a:bodyPr>
-          <a:lstStyle/>
-          <a:p>
-            <a:pPr algn="l">
-              <a:defRPr sz="900" b="0">
-                <a:solidFill>
-                  <a:srgbClr val="54575E"/>
-                </a:solidFill>
-              </a:defRPr>
-            </a:pPr>
-            <a:r>
-              <a:t>With coverage</a:t>
-            </a:r>
-          </a:p>
-        </p:txBody>
-      </p:sp>
-      <p:sp>
-        <p:nvSpPr>
-          <p:cNvPr id="28" name="TextBox 27"/>
-          <p:cNvSpPr txBox="1"/>
-          <p:nvPr/>
-        </p:nvSpPr>
-        <p:spPr>
-          <a:xfrm>
-            <a:off x="457200" y="3017520"/>
-            <a:ext cx="3657600" cy="274320"/>
-          </a:xfrm>
-          <a:prstGeom prst="rect">
-            <a:avLst/>
-          </a:prstGeom>
-          <a:noFill/>
-        </p:spPr>
-        <p:txBody>
-          <a:bodyPr wrap="square">
-            <a:spAutoFit/>
-          </a:bodyPr>
-          <a:lstStyle/>
-          <a:p>
-            <a:pPr algn="l">
+            <a:pPr>
               <a:defRPr sz="1400" b="1">
                 <a:solidFill>
                   <a:srgbClr val="172852"/>
@@ -17945,15 +17300,15 @@
       </p:sp>
       <p:graphicFrame>
         <p:nvGraphicFramePr>
-          <p:cNvPr id="29" name="Table 28"/>
+          <p:cNvPr id="5" name="Table 4"/>
           <p:cNvGraphicFramePr>
             <a:graphicFrameLocks noGrp="1"/>
           </p:cNvGraphicFramePr>
           <p:nvPr/>
         </p:nvGraphicFramePr>
         <p:xfrm>
-          <a:off x="457200" y="3383280"/>
-          <a:ext cx="5029200" cy="1097280"/>
+          <a:off x="457200" y="3108960"/>
+          <a:ext cx="5943600" cy="1097280"/>
         </p:xfrm>
         <a:graphic>
           <a:graphicData uri="http://schemas.openxmlformats.org/drawingml/2006/table">
@@ -17962,10 +17317,10 @@
                 <a:tableStyleId>{5C22544A-7EE6-4342-B048-85BDC9FD1C3A}</a:tableStyleId>
               </a:tblPr>
               <a:tblGrid>
-                <a:gridCol w="1828800"/>
-                <a:gridCol w="1097280"/>
-                <a:gridCol w="1097280"/>
-                <a:gridCol w="1005840"/>
+                <a:gridCol w="2286000"/>
+                <a:gridCol w="1371600"/>
+                <a:gridCol w="1371600"/>
+                <a:gridCol w="914400"/>
               </a:tblGrid>
               <a:tr h="274320">
                 <a:tc>
@@ -17973,8 +17328,8 @@
                     <a:bodyPr/>
                     <a:lstStyle/>
                     <a:p>
-                      <a:pPr>
-                        <a:defRPr sz="1000" b="1">
+                      <a:pPr algn="ctr">
+                        <a:defRPr sz="900" b="1">
                           <a:solidFill>
                             <a:srgbClr val="FFFFFF"/>
                           </a:solidFill>
@@ -17996,8 +17351,8 @@
                     <a:bodyPr/>
                     <a:lstStyle/>
                     <a:p>
-                      <a:pPr>
-                        <a:defRPr sz="1000" b="1">
+                      <a:pPr algn="ctr">
+                        <a:defRPr sz="900" b="1">
                           <a:solidFill>
                             <a:srgbClr val="FFFFFF"/>
                           </a:solidFill>
@@ -18019,8 +17374,8 @@
                     <a:bodyPr/>
                     <a:lstStyle/>
                     <a:p>
-                      <a:pPr>
-                        <a:defRPr sz="1000" b="1">
+                      <a:pPr algn="ctr">
+                        <a:defRPr sz="900" b="1">
                           <a:solidFill>
                             <a:srgbClr val="FFFFFF"/>
                           </a:solidFill>
@@ -18042,15 +17397,15 @@
                     <a:bodyPr/>
                     <a:lstStyle/>
                     <a:p>
-                      <a:pPr>
-                        <a:defRPr sz="1000" b="1">
+                      <a:pPr algn="ctr">
+                        <a:defRPr sz="900" b="1">
                           <a:solidFill>
                             <a:srgbClr val="FFFFFF"/>
                           </a:solidFill>
                         </a:defRPr>
                       </a:pPr>
                       <a:r>
-                        <a:t>Coverage %</a:t>
+                        <a:t>Coverage</a:t>
                       </a:r>
                     </a:p>
                   </a:txBody>
@@ -18067,12 +17422,8 @@
                     <a:bodyPr/>
                     <a:lstStyle/>
                     <a:p>
-                      <a:pPr>
-                        <a:defRPr sz="900">
-                          <a:solidFill>
-                            <a:srgbClr val="172852"/>
-                          </a:solidFill>
-                        </a:defRPr>
+                      <a:pPr algn="ctr">
+                        <a:defRPr sz="900" b="0"/>
                       </a:pPr>
                       <a:r>
                         <a:t>Commercial (incl. Federal)</a:t>
@@ -18086,12 +17437,8 @@
                     <a:bodyPr/>
                     <a:lstStyle/>
                     <a:p>
-                      <a:pPr>
-                        <a:defRPr sz="900">
-                          <a:solidFill>
-                            <a:srgbClr val="172852"/>
-                          </a:solidFill>
-                        </a:defRPr>
+                      <a:pPr algn="ctr">
+                        <a:defRPr sz="900" b="0"/>
                       </a:pPr>
                       <a:r>
                         <a:t>186,600,000</a:t>
@@ -18105,12 +17452,8 @@
                     <a:bodyPr/>
                     <a:lstStyle/>
                     <a:p>
-                      <a:pPr>
-                        <a:defRPr sz="900">
-                          <a:solidFill>
-                            <a:srgbClr val="172852"/>
-                          </a:solidFill>
-                        </a:defRPr>
+                      <a:pPr algn="ctr">
+                        <a:defRPr sz="900" b="0"/>
                       </a:pPr>
                       <a:r>
                         <a:t>6,816,075</a:t>
@@ -18124,15 +17467,11 @@
                     <a:bodyPr/>
                     <a:lstStyle/>
                     <a:p>
-                      <a:pPr>
-                        <a:defRPr sz="900">
-                          <a:solidFill>
-                            <a:srgbClr val="172852"/>
-                          </a:solidFill>
-                        </a:defRPr>
+                      <a:pPr algn="ctr">
+                        <a:defRPr sz="900" b="0"/>
                       </a:pPr>
                       <a:r>
-                        <a:t>3.6%</a:t>
+                        <a:t>3.7%</a:t>
                       </a:r>
                     </a:p>
                   </a:txBody>
@@ -18145,12 +17484,8 @@
                     <a:bodyPr/>
                     <a:lstStyle/>
                     <a:p>
-                      <a:pPr>
-                        <a:defRPr sz="900">
-                          <a:solidFill>
-                            <a:srgbClr val="172852"/>
-                          </a:solidFill>
-                        </a:defRPr>
+                      <a:pPr algn="ctr">
+                        <a:defRPr sz="900" b="0"/>
                       </a:pPr>
                       <a:r>
                         <a:t>Medicare</a:t>
@@ -18159,7 +17494,7 @@
                   </a:txBody>
                   <a:tcPr>
                     <a:solidFill>
-                      <a:srgbClr val="DCEEF4"/>
+                      <a:srgbClr val="F0F8FF"/>
                     </a:solidFill>
                   </a:tcPr>
                 </a:tc>
@@ -18168,12 +17503,8 @@
                     <a:bodyPr/>
                     <a:lstStyle/>
                     <a:p>
-                      <a:pPr>
-                        <a:defRPr sz="900">
-                          <a:solidFill>
-                            <a:srgbClr val="172852"/>
-                          </a:solidFill>
-                        </a:defRPr>
+                      <a:pPr algn="ctr">
+                        <a:defRPr sz="900" b="0"/>
                       </a:pPr>
                       <a:r>
                         <a:t>51,000,000</a:t>
@@ -18182,7 +17513,7 @@
                   </a:txBody>
                   <a:tcPr>
                     <a:solidFill>
-                      <a:srgbClr val="DCEEF4"/>
+                      <a:srgbClr val="F0F8FF"/>
                     </a:solidFill>
                   </a:tcPr>
                 </a:tc>
@@ -18191,12 +17522,8 @@
                     <a:bodyPr/>
                     <a:lstStyle/>
                     <a:p>
-                      <a:pPr>
-                        <a:defRPr sz="900">
-                          <a:solidFill>
-                            <a:srgbClr val="172852"/>
-                          </a:solidFill>
-                        </a:defRPr>
+                      <a:pPr algn="ctr">
+                        <a:defRPr sz="900" b="0"/>
                       </a:pPr>
                       <a:r>
                         <a:t>0</a:t>
@@ -18205,7 +17532,7 @@
                   </a:txBody>
                   <a:tcPr>
                     <a:solidFill>
-                      <a:srgbClr val="DCEEF4"/>
+                      <a:srgbClr val="F0F8FF"/>
                     </a:solidFill>
                   </a:tcPr>
                 </a:tc>
@@ -18214,12 +17541,8 @@
                     <a:bodyPr/>
                     <a:lstStyle/>
                     <a:p>
-                      <a:pPr>
-                        <a:defRPr sz="900">
-                          <a:solidFill>
-                            <a:srgbClr val="172852"/>
-                          </a:solidFill>
-                        </a:defRPr>
+                      <a:pPr algn="ctr">
+                        <a:defRPr sz="900" b="0"/>
                       </a:pPr>
                       <a:r>
                         <a:t>0.0%</a:t>
@@ -18228,7 +17551,7 @@
                   </a:txBody>
                   <a:tcPr>
                     <a:solidFill>
-                      <a:srgbClr val="DCEEF4"/>
+                      <a:srgbClr val="F0F8FF"/>
                     </a:solidFill>
                   </a:tcPr>
                 </a:tc>
@@ -18239,12 +17562,8 @@
                     <a:bodyPr/>
                     <a:lstStyle/>
                     <a:p>
-                      <a:pPr>
-                        <a:defRPr sz="900">
-                          <a:solidFill>
-                            <a:srgbClr val="172852"/>
-                          </a:solidFill>
-                        </a:defRPr>
+                      <a:pPr algn="ctr">
+                        <a:defRPr sz="900" b="0"/>
                       </a:pPr>
                       <a:r>
                         <a:t>Medicaid</a:t>
@@ -18258,12 +17577,8 @@
                     <a:bodyPr/>
                     <a:lstStyle/>
                     <a:p>
-                      <a:pPr>
-                        <a:defRPr sz="900">
-                          <a:solidFill>
-                            <a:srgbClr val="172852"/>
-                          </a:solidFill>
-                        </a:defRPr>
+                      <a:pPr algn="ctr">
+                        <a:defRPr sz="900" b="0"/>
                       </a:pPr>
                       <a:r>
                         <a:t>92,000,000</a:t>
@@ -18277,12 +17592,8 @@
                     <a:bodyPr/>
                     <a:lstStyle/>
                     <a:p>
-                      <a:pPr>
-                        <a:defRPr sz="900">
-                          <a:solidFill>
-                            <a:srgbClr val="172852"/>
-                          </a:solidFill>
-                        </a:defRPr>
+                      <a:pPr algn="ctr">
+                        <a:defRPr sz="900" b="0"/>
                       </a:pPr>
                       <a:r>
                         <a:t>0</a:t>
@@ -18296,467 +17607,11 @@
                     <a:bodyPr/>
                     <a:lstStyle/>
                     <a:p>
-                      <a:pPr>
-                        <a:defRPr sz="900">
-                          <a:solidFill>
-                            <a:srgbClr val="172852"/>
-                          </a:solidFill>
-                        </a:defRPr>
+                      <a:pPr algn="ctr">
+                        <a:defRPr sz="900" b="0"/>
                       </a:pPr>
                       <a:r>
                         <a:t>0.0%</a:t>
-                      </a:r>
-                    </a:p>
-                  </a:txBody>
-                  <a:tcPr/>
-                </a:tc>
-              </a:tr>
-            </a:tbl>
-          </a:graphicData>
-        </a:graphic>
-      </p:graphicFrame>
-      <p:sp>
-        <p:nvSpPr>
-          <p:cNvPr id="30" name="TextBox 29"/>
-          <p:cNvSpPr txBox="1"/>
-          <p:nvPr/>
-        </p:nvSpPr>
-        <p:spPr>
-          <a:xfrm>
-            <a:off x="5943600" y="3017520"/>
-            <a:ext cx="2743200" cy="274320"/>
-          </a:xfrm>
-          <a:prstGeom prst="rect">
-            <a:avLst/>
-          </a:prstGeom>
-          <a:noFill/>
-        </p:spPr>
-        <p:txBody>
-          <a:bodyPr wrap="square">
-            <a:spAutoFit/>
-          </a:bodyPr>
-          <a:lstStyle/>
-          <a:p>
-            <a:pPr algn="l">
-              <a:defRPr sz="1400" b="1">
-                <a:solidFill>
-                  <a:srgbClr val="172852"/>
-                </a:solidFill>
-              </a:defRPr>
-            </a:pPr>
-            <a:r>
-              <a:t>Top Plans by Lives</a:t>
-            </a:r>
-          </a:p>
-        </p:txBody>
-      </p:sp>
-      <p:graphicFrame>
-        <p:nvGraphicFramePr>
-          <p:cNvPr id="31" name="Table 30"/>
-          <p:cNvGraphicFramePr>
-            <a:graphicFrameLocks noGrp="1"/>
-          </p:cNvGraphicFramePr>
-          <p:nvPr/>
-        </p:nvGraphicFramePr>
-        <p:xfrm>
-          <a:off x="5943600" y="3383280"/>
-          <a:ext cx="3017520" cy="1371600"/>
-        </p:xfrm>
-        <a:graphic>
-          <a:graphicData uri="http://schemas.openxmlformats.org/drawingml/2006/table">
-            <a:tbl>
-              <a:tblPr firstRow="1" bandRow="1">
-                <a:tableStyleId>{5C22544A-7EE6-4342-B048-85BDC9FD1C3A}</a:tableStyleId>
-              </a:tblPr>
-              <a:tblGrid>
-                <a:gridCol w="1463040"/>
-                <a:gridCol w="822960"/>
-                <a:gridCol w="731520"/>
-              </a:tblGrid>
-              <a:tr h="228600">
-                <a:tc>
-                  <a:txBody>
-                    <a:bodyPr/>
-                    <a:lstStyle/>
-                    <a:p>
-                      <a:pPr>
-                        <a:defRPr sz="1000" b="1">
-                          <a:solidFill>
-                            <a:srgbClr val="FFFFFF"/>
-                          </a:solidFill>
-                        </a:defRPr>
-                      </a:pPr>
-                      <a:r>
-                        <a:t>Plan Name</a:t>
-                      </a:r>
-                    </a:p>
-                  </a:txBody>
-                  <a:tcPr>
-                    <a:solidFill>
-                      <a:srgbClr val="0D7AB5"/>
-                    </a:solidFill>
-                  </a:tcPr>
-                </a:tc>
-                <a:tc>
-                  <a:txBody>
-                    <a:bodyPr/>
-                    <a:lstStyle/>
-                    <a:p>
-                      <a:pPr>
-                        <a:defRPr sz="1000" b="1">
-                          <a:solidFill>
-                            <a:srgbClr val="FFFFFF"/>
-                          </a:solidFill>
-                        </a:defRPr>
-                      </a:pPr>
-                      <a:r>
-                        <a:t>Lives</a:t>
-                      </a:r>
-                    </a:p>
-                  </a:txBody>
-                  <a:tcPr>
-                    <a:solidFill>
-                      <a:srgbClr val="0D7AB5"/>
-                    </a:solidFill>
-                  </a:tcPr>
-                </a:tc>
-                <a:tc>
-                  <a:txBody>
-                    <a:bodyPr/>
-                    <a:lstStyle/>
-                    <a:p>
-                      <a:pPr>
-                        <a:defRPr sz="1000" b="1">
-                          <a:solidFill>
-                            <a:srgbClr val="FFFFFF"/>
-                          </a:solidFill>
-                        </a:defRPr>
-                      </a:pPr>
-                      <a:r>
-                        <a:t>Type</a:t>
-                      </a:r>
-                    </a:p>
-                  </a:txBody>
-                  <a:tcPr>
-                    <a:solidFill>
-                      <a:srgbClr val="0D7AB5"/>
-                    </a:solidFill>
-                  </a:tcPr>
-                </a:tc>
-              </a:tr>
-              <a:tr h="228600">
-                <a:tc>
-                  <a:txBody>
-                    <a:bodyPr/>
-                    <a:lstStyle/>
-                    <a:p>
-                      <a:pPr>
-                        <a:defRPr sz="900">
-                          <a:solidFill>
-                            <a:srgbClr val="172852"/>
-                          </a:solidFill>
-                        </a:defRPr>
-                      </a:pPr>
-                      <a:r>
-                        <a:t>TRICARE Uniform Formulary</a:t>
-                      </a:r>
-                    </a:p>
-                  </a:txBody>
-                  <a:tcPr/>
-                </a:tc>
-                <a:tc>
-                  <a:txBody>
-                    <a:bodyPr/>
-                    <a:lstStyle/>
-                    <a:p>
-                      <a:pPr>
-                        <a:defRPr sz="900">
-                          <a:solidFill>
-                            <a:srgbClr val="172852"/>
-                          </a:solidFill>
-                        </a:defRPr>
-                      </a:pPr>
-                      <a:r>
-                        <a:t>5,749,433</a:t>
-                      </a:r>
-                    </a:p>
-                  </a:txBody>
-                  <a:tcPr/>
-                </a:tc>
-                <a:tc>
-                  <a:txBody>
-                    <a:bodyPr/>
-                    <a:lstStyle/>
-                    <a:p>
-                      <a:pPr>
-                        <a:defRPr sz="900">
-                          <a:solidFill>
-                            <a:srgbClr val="172852"/>
-                          </a:solidFill>
-                        </a:defRPr>
-                      </a:pPr>
-                      <a:r>
-                        <a:t>Fed Prog</a:t>
-                      </a:r>
-                    </a:p>
-                  </a:txBody>
-                  <a:tcPr/>
-                </a:tc>
-              </a:tr>
-              <a:tr h="228600">
-                <a:tc>
-                  <a:txBody>
-                    <a:bodyPr/>
-                    <a:lstStyle/>
-                    <a:p>
-                      <a:pPr>
-                        <a:defRPr sz="900">
-                          <a:solidFill>
-                            <a:srgbClr val="172852"/>
-                          </a:solidFill>
-                        </a:defRPr>
-                      </a:pPr>
-                      <a:r>
-                        <a:t>CHI Franciscan</a:t>
-                      </a:r>
-                    </a:p>
-                  </a:txBody>
-                  <a:tcPr>
-                    <a:solidFill>
-                      <a:srgbClr val="DCEEF4"/>
-                    </a:solidFill>
-                  </a:tcPr>
-                </a:tc>
-                <a:tc>
-                  <a:txBody>
-                    <a:bodyPr/>
-                    <a:lstStyle/>
-                    <a:p>
-                      <a:pPr>
-                        <a:defRPr sz="900">
-                          <a:solidFill>
-                            <a:srgbClr val="172852"/>
-                          </a:solidFill>
-                        </a:defRPr>
-                      </a:pPr>
-                      <a:r>
-                        <a:t>217,484</a:t>
-                      </a:r>
-                    </a:p>
-                  </a:txBody>
-                  <a:tcPr>
-                    <a:solidFill>
-                      <a:srgbClr val="DCEEF4"/>
-                    </a:solidFill>
-                  </a:tcPr>
-                </a:tc>
-                <a:tc>
-                  <a:txBody>
-                    <a:bodyPr/>
-                    <a:lstStyle/>
-                    <a:p>
-                      <a:pPr>
-                        <a:defRPr sz="900">
-                          <a:solidFill>
-                            <a:srgbClr val="172852"/>
-                          </a:solidFill>
-                        </a:defRPr>
-                      </a:pPr>
-                      <a:r>
-                        <a:t>Employer</a:t>
-                      </a:r>
-                    </a:p>
-                  </a:txBody>
-                  <a:tcPr>
-                    <a:solidFill>
-                      <a:srgbClr val="DCEEF4"/>
-                    </a:solidFill>
-                  </a:tcPr>
-                </a:tc>
-              </a:tr>
-              <a:tr h="228600">
-                <a:tc>
-                  <a:txBody>
-                    <a:bodyPr/>
-                    <a:lstStyle/>
-                    <a:p>
-                      <a:pPr>
-                        <a:defRPr sz="900">
-                          <a:solidFill>
-                            <a:srgbClr val="172852"/>
-                          </a:solidFill>
-                        </a:defRPr>
-                      </a:pPr>
-                      <a:r>
-                        <a:t>MGM Resorts International</a:t>
-                      </a:r>
-                    </a:p>
-                  </a:txBody>
-                  <a:tcPr/>
-                </a:tc>
-                <a:tc>
-                  <a:txBody>
-                    <a:bodyPr/>
-                    <a:lstStyle/>
-                    <a:p>
-                      <a:pPr>
-                        <a:defRPr sz="900">
-                          <a:solidFill>
-                            <a:srgbClr val="172852"/>
-                          </a:solidFill>
-                        </a:defRPr>
-                      </a:pPr>
-                      <a:r>
-                        <a:t>183,545</a:t>
-                      </a:r>
-                    </a:p>
-                  </a:txBody>
-                  <a:tcPr/>
-                </a:tc>
-                <a:tc>
-                  <a:txBody>
-                    <a:bodyPr/>
-                    <a:lstStyle/>
-                    <a:p>
-                      <a:pPr>
-                        <a:defRPr sz="900">
-                          <a:solidFill>
-                            <a:srgbClr val="172852"/>
-                          </a:solidFill>
-                        </a:defRPr>
-                      </a:pPr>
-                      <a:r>
-                        <a:t>Employer</a:t>
-                      </a:r>
-                    </a:p>
-                  </a:txBody>
-                  <a:tcPr/>
-                </a:tc>
-              </a:tr>
-              <a:tr h="228600">
-                <a:tc>
-                  <a:txBody>
-                    <a:bodyPr/>
-                    <a:lstStyle/>
-                    <a:p>
-                      <a:pPr>
-                        <a:defRPr sz="900">
-                          <a:solidFill>
-                            <a:srgbClr val="172852"/>
-                          </a:solidFill>
-                        </a:defRPr>
-                      </a:pPr>
-                      <a:r>
-                        <a:t>General Electric</a:t>
-                      </a:r>
-                    </a:p>
-                  </a:txBody>
-                  <a:tcPr>
-                    <a:solidFill>
-                      <a:srgbClr val="DCEEF4"/>
-                    </a:solidFill>
-                  </a:tcPr>
-                </a:tc>
-                <a:tc>
-                  <a:txBody>
-                    <a:bodyPr/>
-                    <a:lstStyle/>
-                    <a:p>
-                      <a:pPr>
-                        <a:defRPr sz="900">
-                          <a:solidFill>
-                            <a:srgbClr val="172852"/>
-                          </a:solidFill>
-                        </a:defRPr>
-                      </a:pPr>
-                      <a:r>
-                        <a:t>118,127</a:t>
-                      </a:r>
-                    </a:p>
-                  </a:txBody>
-                  <a:tcPr>
-                    <a:solidFill>
-                      <a:srgbClr val="DCEEF4"/>
-                    </a:solidFill>
-                  </a:tcPr>
-                </a:tc>
-                <a:tc>
-                  <a:txBody>
-                    <a:bodyPr/>
-                    <a:lstStyle/>
-                    <a:p>
-                      <a:pPr>
-                        <a:defRPr sz="900">
-                          <a:solidFill>
-                            <a:srgbClr val="172852"/>
-                          </a:solidFill>
-                        </a:defRPr>
-                      </a:pPr>
-                      <a:r>
-                        <a:t>Employer</a:t>
-                      </a:r>
-                    </a:p>
-                  </a:txBody>
-                  <a:tcPr>
-                    <a:solidFill>
-                      <a:srgbClr val="DCEEF4"/>
-                    </a:solidFill>
-                  </a:tcPr>
-                </a:tc>
-              </a:tr>
-              <a:tr h="228600">
-                <a:tc>
-                  <a:txBody>
-                    <a:bodyPr/>
-                    <a:lstStyle/>
-                    <a:p>
-                      <a:pPr>
-                        <a:defRPr sz="900">
-                          <a:solidFill>
-                            <a:srgbClr val="172852"/>
-                          </a:solidFill>
-                        </a:defRPr>
-                      </a:pPr>
-                      <a:r>
-                        <a:t>Apple</a:t>
-                      </a:r>
-                    </a:p>
-                  </a:txBody>
-                  <a:tcPr/>
-                </a:tc>
-                <a:tc>
-                  <a:txBody>
-                    <a:bodyPr/>
-                    <a:lstStyle/>
-                    <a:p>
-                      <a:pPr>
-                        <a:defRPr sz="900">
-                          <a:solidFill>
-                            <a:srgbClr val="172852"/>
-                          </a:solidFill>
-                        </a:defRPr>
-                      </a:pPr>
-                      <a:r>
-                        <a:t>106,071</a:t>
-                      </a:r>
-                    </a:p>
-                  </a:txBody>
-                  <a:tcPr/>
-                </a:tc>
-                <a:tc>
-                  <a:txBody>
-                    <a:bodyPr/>
-                    <a:lstStyle/>
-                    <a:p>
-                      <a:pPr>
-                        <a:defRPr sz="900">
-                          <a:solidFill>
-                            <a:srgbClr val="172852"/>
-                          </a:solidFill>
-                        </a:defRPr>
-                      </a:pPr>
-                      <a:r>
-                        <a:t>Employer</a:t>
                       </a:r>
                     </a:p>
                   </a:txBody>
@@ -18802,104 +17657,200 @@
           <a:p/>
         </p:txBody>
       </p:sp>
+      <p:graphicFrame>
+        <p:nvGraphicFramePr>
+          <p:cNvPr id="3" name="Table 2"/>
+          <p:cNvGraphicFramePr>
+            <a:graphicFrameLocks noGrp="1"/>
+          </p:cNvGraphicFramePr>
+          <p:nvPr/>
+        </p:nvGraphicFramePr>
+        <p:xfrm>
+          <a:off x="457200" y="1371600"/>
+          <a:ext cx="7315200" cy="822960"/>
+        </p:xfrm>
+        <a:graphic>
+          <a:graphicData uri="http://schemas.openxmlformats.org/drawingml/2006/table">
+            <a:tbl>
+              <a:tblPr firstRow="1" bandRow="1">
+                <a:tableStyleId>{5C22544A-7EE6-4342-B048-85BDC9FD1C3A}</a:tableStyleId>
+              </a:tblPr>
+              <a:tblGrid>
+                <a:gridCol w="1828800"/>
+                <a:gridCol w="1828800"/>
+                <a:gridCol w="1828800"/>
+                <a:gridCol w="1828800"/>
+              </a:tblGrid>
+              <a:tr h="411480">
+                <a:tc>
+                  <a:txBody>
+                    <a:bodyPr/>
+                    <a:lstStyle/>
+                    <a:p>
+                      <a:pPr algn="ctr">
+                        <a:defRPr sz="1000" b="1">
+                          <a:solidFill>
+                            <a:srgbClr val="172852"/>
+                          </a:solidFill>
+                        </a:defRPr>
+                      </a:pPr>
+                      <a:r>
+                        <a:t>Total Contracts</a:t>
+                      </a:r>
+                    </a:p>
+                  </a:txBody>
+                  <a:tcPr/>
+                </a:tc>
+                <a:tc>
+                  <a:txBody>
+                    <a:bodyPr/>
+                    <a:lstStyle/>
+                    <a:p>
+                      <a:pPr algn="ctr">
+                        <a:defRPr sz="1000" b="1">
+                          <a:solidFill>
+                            <a:srgbClr val="172852"/>
+                          </a:solidFill>
+                        </a:defRPr>
+                      </a:pPr>
+                      <a:r>
+                        <a:t>Signed</a:t>
+                      </a:r>
+                    </a:p>
+                  </a:txBody>
+                  <a:tcPr/>
+                </a:tc>
+                <a:tc>
+                  <a:txBody>
+                    <a:bodyPr/>
+                    <a:lstStyle/>
+                    <a:p>
+                      <a:pPr algn="ctr">
+                        <a:defRPr sz="1000" b="1">
+                          <a:solidFill>
+                            <a:srgbClr val="172852"/>
+                          </a:solidFill>
+                        </a:defRPr>
+                      </a:pPr>
+                      <a:r>
+                        <a:t>Submitted</a:t>
+                      </a:r>
+                    </a:p>
+                  </a:txBody>
+                  <a:tcPr/>
+                </a:tc>
+                <a:tc>
+                  <a:txBody>
+                    <a:bodyPr/>
+                    <a:lstStyle/>
+                    <a:p>
+                      <a:pPr algn="ctr">
+                        <a:defRPr sz="1000" b="1">
+                          <a:solidFill>
+                            <a:srgbClr val="172852"/>
+                          </a:solidFill>
+                        </a:defRPr>
+                      </a:pPr>
+                      <a:r>
+                        <a:t>In Negotiation</a:t>
+                      </a:r>
+                    </a:p>
+                  </a:txBody>
+                  <a:tcPr/>
+                </a:tc>
+              </a:tr>
+              <a:tr h="411480">
+                <a:tc>
+                  <a:txBody>
+                    <a:bodyPr/>
+                    <a:lstStyle/>
+                    <a:p>
+                      <a:pPr algn="ctr">
+                        <a:defRPr sz="2800" b="1">
+                          <a:solidFill>
+                            <a:srgbClr val="0D7AB5"/>
+                          </a:solidFill>
+                        </a:defRPr>
+                      </a:pPr>
+                      <a:r>
+                        <a:t>8</a:t>
+                      </a:r>
+                    </a:p>
+                  </a:txBody>
+                  <a:tcPr/>
+                </a:tc>
+                <a:tc>
+                  <a:txBody>
+                    <a:bodyPr/>
+                    <a:lstStyle/>
+                    <a:p>
+                      <a:pPr algn="ctr">
+                        <a:defRPr sz="2800" b="1">
+                          <a:solidFill>
+                            <a:srgbClr val="0D7AB5"/>
+                          </a:solidFill>
+                        </a:defRPr>
+                      </a:pPr>
+                      <a:r>
+                        <a:t>3</a:t>
+                      </a:r>
+                    </a:p>
+                  </a:txBody>
+                  <a:tcPr/>
+                </a:tc>
+                <a:tc>
+                  <a:txBody>
+                    <a:bodyPr/>
+                    <a:lstStyle/>
+                    <a:p>
+                      <a:pPr algn="ctr">
+                        <a:defRPr sz="2800" b="1">
+                          <a:solidFill>
+                            <a:srgbClr val="0D7AB5"/>
+                          </a:solidFill>
+                        </a:defRPr>
+                      </a:pPr>
+                      <a:r>
+                        <a:t>4</a:t>
+                      </a:r>
+                    </a:p>
+                  </a:txBody>
+                  <a:tcPr/>
+                </a:tc>
+                <a:tc>
+                  <a:txBody>
+                    <a:bodyPr/>
+                    <a:lstStyle/>
+                    <a:p>
+                      <a:pPr algn="ctr">
+                        <a:defRPr sz="2800" b="1">
+                          <a:solidFill>
+                            <a:srgbClr val="0D7AB5"/>
+                          </a:solidFill>
+                        </a:defRPr>
+                      </a:pPr>
+                      <a:r>
+                        <a:t>1</a:t>
+                      </a:r>
+                    </a:p>
+                  </a:txBody>
+                  <a:tcPr/>
+                </a:tc>
+              </a:tr>
+            </a:tbl>
+          </a:graphicData>
+        </a:graphic>
+      </p:graphicFrame>
       <p:sp>
         <p:nvSpPr>
-          <p:cNvPr id="3" name="Rounded Rectangle 2"/>
-          <p:cNvSpPr/>
-          <p:nvPr/>
-        </p:nvSpPr>
-        <p:spPr>
-          <a:xfrm>
-            <a:off x="731520" y="1645920"/>
-            <a:ext cx="1828800" cy="1097280"/>
-          </a:xfrm>
-          <a:prstGeom prst="roundRect">
-            <a:avLst/>
-          </a:prstGeom>
-          <a:solidFill>
-            <a:srgbClr val="FFFFFF"/>
-          </a:solidFill>
-          <a:ln>
-            <a:solidFill>
-              <a:srgbClr val="E2E8F0"/>
-            </a:solidFill>
-          </a:ln>
-        </p:spPr>
-        <p:style>
-          <a:lnRef idx="1">
-            <a:schemeClr val="accent1"/>
-          </a:lnRef>
-          <a:fillRef idx="3">
-            <a:schemeClr val="accent1"/>
-          </a:fillRef>
-          <a:effectRef idx="2">
-            <a:schemeClr val="accent1"/>
-          </a:effectRef>
-          <a:fontRef idx="minor">
-            <a:schemeClr val="lt1"/>
-          </a:fontRef>
-        </p:style>
-        <p:txBody>
-          <a:bodyPr rtlCol="0" anchor="ctr"/>
-          <a:lstStyle/>
-          <a:p>
-            <a:pPr algn="ctr"/>
-          </a:p>
-        </p:txBody>
-      </p:sp>
-      <p:sp>
-        <p:nvSpPr>
-          <p:cNvPr id="4" name="Rectangle 3"/>
-          <p:cNvSpPr/>
-          <p:nvPr/>
-        </p:nvSpPr>
-        <p:spPr>
-          <a:xfrm>
-            <a:off x="731520" y="2651760"/>
-            <a:ext cx="1828800" cy="91440"/>
-          </a:xfrm>
-          <a:prstGeom prst="rect">
-            <a:avLst/>
-          </a:prstGeom>
-          <a:solidFill>
-            <a:srgbClr val="00B2E3"/>
-          </a:solidFill>
-          <a:ln>
-            <a:noFill/>
-          </a:ln>
-        </p:spPr>
-        <p:style>
-          <a:lnRef idx="1">
-            <a:schemeClr val="accent1"/>
-          </a:lnRef>
-          <a:fillRef idx="3">
-            <a:schemeClr val="accent1"/>
-          </a:fillRef>
-          <a:effectRef idx="2">
-            <a:schemeClr val="accent1"/>
-          </a:effectRef>
-          <a:fontRef idx="minor">
-            <a:schemeClr val="lt1"/>
-          </a:fontRef>
-        </p:style>
-        <p:txBody>
-          <a:bodyPr rtlCol="0" anchor="ctr"/>
-          <a:lstStyle/>
-          <a:p>
-            <a:pPr algn="ctr"/>
-          </a:p>
-        </p:txBody>
-      </p:sp>
-      <p:sp>
-        <p:nvSpPr>
-          <p:cNvPr id="5" name="TextBox 4"/>
+          <p:cNvPr id="4" name="TextBox 3"/>
           <p:cNvSpPr txBox="1"/>
           <p:nvPr/>
         </p:nvSpPr>
         <p:spPr>
           <a:xfrm>
-            <a:off x="822960" y="1737360"/>
-            <a:ext cx="1645920" cy="274320"/>
+            <a:off x="457200" y="2468880"/>
+            <a:ext cx="3657600" cy="457200"/>
           </a:xfrm>
           <a:prstGeom prst="rect">
             <a:avLst/>
@@ -18907,696 +17858,12 @@
           <a:noFill/>
         </p:spPr>
         <p:txBody>
-          <a:bodyPr wrap="square">
+          <a:bodyPr wrap="none">
             <a:spAutoFit/>
           </a:bodyPr>
           <a:lstStyle/>
           <a:p>
-            <a:pPr algn="l">
-              <a:defRPr sz="1000" b="0">
-                <a:solidFill>
-                  <a:srgbClr val="54575E"/>
-                </a:solidFill>
-              </a:defRPr>
-            </a:pPr>
-            <a:r>
-              <a:t>Total Contracts</a:t>
-            </a:r>
-          </a:p>
-        </p:txBody>
-      </p:sp>
-      <p:sp>
-        <p:nvSpPr>
-          <p:cNvPr id="6" name="TextBox 5"/>
-          <p:cNvSpPr txBox="1"/>
-          <p:nvPr/>
-        </p:nvSpPr>
-        <p:spPr>
-          <a:xfrm>
-            <a:off x="822960" y="1965960"/>
-            <a:ext cx="1645920" cy="365760"/>
-          </a:xfrm>
-          <a:prstGeom prst="rect">
-            <a:avLst/>
-          </a:prstGeom>
-          <a:noFill/>
-        </p:spPr>
-        <p:txBody>
-          <a:bodyPr wrap="square">
-            <a:spAutoFit/>
-          </a:bodyPr>
-          <a:lstStyle/>
-          <a:p>
-            <a:pPr algn="l">
-              <a:defRPr sz="2400" b="1">
-                <a:solidFill>
-                  <a:srgbClr val="172852"/>
-                </a:solidFill>
-              </a:defRPr>
-            </a:pPr>
-            <a:r>
-              <a:t>8</a:t>
-            </a:r>
-          </a:p>
-        </p:txBody>
-      </p:sp>
-      <p:sp>
-        <p:nvSpPr>
-          <p:cNvPr id="7" name="TextBox 6"/>
-          <p:cNvSpPr txBox="1"/>
-          <p:nvPr/>
-        </p:nvSpPr>
-        <p:spPr>
-          <a:xfrm>
-            <a:off x="822960" y="2377440"/>
-            <a:ext cx="1645920" cy="274320"/>
-          </a:xfrm>
-          <a:prstGeom prst="rect">
-            <a:avLst/>
-          </a:prstGeom>
-          <a:noFill/>
-        </p:spPr>
-        <p:txBody>
-          <a:bodyPr wrap="square">
-            <a:spAutoFit/>
-          </a:bodyPr>
-          <a:lstStyle/>
-          <a:p>
-            <a:pPr algn="l">
-              <a:defRPr sz="900" b="0">
-                <a:solidFill>
-                  <a:srgbClr val="54575E"/>
-                </a:solidFill>
-              </a:defRPr>
-            </a:pPr>
-            <a:r>
-              <a:t>Active negotiations</a:t>
-            </a:r>
-          </a:p>
-        </p:txBody>
-      </p:sp>
-      <p:sp>
-        <p:nvSpPr>
-          <p:cNvPr id="8" name="Rounded Rectangle 7"/>
-          <p:cNvSpPr/>
-          <p:nvPr/>
-        </p:nvSpPr>
-        <p:spPr>
-          <a:xfrm>
-            <a:off x="2834639" y="1645920"/>
-            <a:ext cx="1828800" cy="1097280"/>
-          </a:xfrm>
-          <a:prstGeom prst="roundRect">
-            <a:avLst/>
-          </a:prstGeom>
-          <a:solidFill>
-            <a:srgbClr val="FFFFFF"/>
-          </a:solidFill>
-          <a:ln>
-            <a:solidFill>
-              <a:srgbClr val="E2E8F0"/>
-            </a:solidFill>
-          </a:ln>
-        </p:spPr>
-        <p:style>
-          <a:lnRef idx="1">
-            <a:schemeClr val="accent1"/>
-          </a:lnRef>
-          <a:fillRef idx="3">
-            <a:schemeClr val="accent1"/>
-          </a:fillRef>
-          <a:effectRef idx="2">
-            <a:schemeClr val="accent1"/>
-          </a:effectRef>
-          <a:fontRef idx="minor">
-            <a:schemeClr val="lt1"/>
-          </a:fontRef>
-        </p:style>
-        <p:txBody>
-          <a:bodyPr rtlCol="0" anchor="ctr"/>
-          <a:lstStyle/>
-          <a:p>
-            <a:pPr algn="ctr"/>
-          </a:p>
-        </p:txBody>
-      </p:sp>
-      <p:sp>
-        <p:nvSpPr>
-          <p:cNvPr id="9" name="Rectangle 8"/>
-          <p:cNvSpPr/>
-          <p:nvPr/>
-        </p:nvSpPr>
-        <p:spPr>
-          <a:xfrm>
-            <a:off x="2834639" y="2651760"/>
-            <a:ext cx="1828800" cy="91440"/>
-          </a:xfrm>
-          <a:prstGeom prst="rect">
-            <a:avLst/>
-          </a:prstGeom>
-          <a:solidFill>
-            <a:srgbClr val="10B981"/>
-          </a:solidFill>
-          <a:ln>
-            <a:noFill/>
-          </a:ln>
-        </p:spPr>
-        <p:style>
-          <a:lnRef idx="1">
-            <a:schemeClr val="accent1"/>
-          </a:lnRef>
-          <a:fillRef idx="3">
-            <a:schemeClr val="accent1"/>
-          </a:fillRef>
-          <a:effectRef idx="2">
-            <a:schemeClr val="accent1"/>
-          </a:effectRef>
-          <a:fontRef idx="minor">
-            <a:schemeClr val="lt1"/>
-          </a:fontRef>
-        </p:style>
-        <p:txBody>
-          <a:bodyPr rtlCol="0" anchor="ctr"/>
-          <a:lstStyle/>
-          <a:p>
-            <a:pPr algn="ctr"/>
-          </a:p>
-        </p:txBody>
-      </p:sp>
-      <p:sp>
-        <p:nvSpPr>
-          <p:cNvPr id="10" name="TextBox 9"/>
-          <p:cNvSpPr txBox="1"/>
-          <p:nvPr/>
-        </p:nvSpPr>
-        <p:spPr>
-          <a:xfrm>
-            <a:off x="2926079" y="1737360"/>
-            <a:ext cx="1645920" cy="274320"/>
-          </a:xfrm>
-          <a:prstGeom prst="rect">
-            <a:avLst/>
-          </a:prstGeom>
-          <a:noFill/>
-        </p:spPr>
-        <p:txBody>
-          <a:bodyPr wrap="square">
-            <a:spAutoFit/>
-          </a:bodyPr>
-          <a:lstStyle/>
-          <a:p>
-            <a:pPr algn="l">
-              <a:defRPr sz="1000" b="0">
-                <a:solidFill>
-                  <a:srgbClr val="54575E"/>
-                </a:solidFill>
-              </a:defRPr>
-            </a:pPr>
-            <a:r>
-              <a:t>Signed</a:t>
-            </a:r>
-          </a:p>
-        </p:txBody>
-      </p:sp>
-      <p:sp>
-        <p:nvSpPr>
-          <p:cNvPr id="11" name="TextBox 10"/>
-          <p:cNvSpPr txBox="1"/>
-          <p:nvPr/>
-        </p:nvSpPr>
-        <p:spPr>
-          <a:xfrm>
-            <a:off x="2926079" y="1965960"/>
-            <a:ext cx="1645920" cy="365760"/>
-          </a:xfrm>
-          <a:prstGeom prst="rect">
-            <a:avLst/>
-          </a:prstGeom>
-          <a:noFill/>
-        </p:spPr>
-        <p:txBody>
-          <a:bodyPr wrap="square">
-            <a:spAutoFit/>
-          </a:bodyPr>
-          <a:lstStyle/>
-          <a:p>
-            <a:pPr algn="l">
-              <a:defRPr sz="2400" b="1">
-                <a:solidFill>
-                  <a:srgbClr val="172852"/>
-                </a:solidFill>
-              </a:defRPr>
-            </a:pPr>
-            <a:r>
-              <a:t>3</a:t>
-            </a:r>
-          </a:p>
-        </p:txBody>
-      </p:sp>
-      <p:sp>
-        <p:nvSpPr>
-          <p:cNvPr id="12" name="TextBox 11"/>
-          <p:cNvSpPr txBox="1"/>
-          <p:nvPr/>
-        </p:nvSpPr>
-        <p:spPr>
-          <a:xfrm>
-            <a:off x="2926079" y="2377440"/>
-            <a:ext cx="1645920" cy="274320"/>
-          </a:xfrm>
-          <a:prstGeom prst="rect">
-            <a:avLst/>
-          </a:prstGeom>
-          <a:noFill/>
-        </p:spPr>
-        <p:txBody>
-          <a:bodyPr wrap="square">
-            <a:spAutoFit/>
-          </a:bodyPr>
-          <a:lstStyle/>
-          <a:p>
-            <a:pPr algn="l">
-              <a:defRPr sz="900" b="0">
-                <a:solidFill>
-                  <a:srgbClr val="54575E"/>
-                </a:solidFill>
-              </a:defRPr>
-            </a:pPr>
-            <a:r>
-              <a:t>Completed deals</a:t>
-            </a:r>
-          </a:p>
-        </p:txBody>
-      </p:sp>
-      <p:sp>
-        <p:nvSpPr>
-          <p:cNvPr id="13" name="Rounded Rectangle 12"/>
-          <p:cNvSpPr/>
-          <p:nvPr/>
-        </p:nvSpPr>
-        <p:spPr>
-          <a:xfrm>
-            <a:off x="4937759" y="1645920"/>
-            <a:ext cx="1828800" cy="1097280"/>
-          </a:xfrm>
-          <a:prstGeom prst="roundRect">
-            <a:avLst/>
-          </a:prstGeom>
-          <a:solidFill>
-            <a:srgbClr val="FFFFFF"/>
-          </a:solidFill>
-          <a:ln>
-            <a:solidFill>
-              <a:srgbClr val="E2E8F0"/>
-            </a:solidFill>
-          </a:ln>
-        </p:spPr>
-        <p:style>
-          <a:lnRef idx="1">
-            <a:schemeClr val="accent1"/>
-          </a:lnRef>
-          <a:fillRef idx="3">
-            <a:schemeClr val="accent1"/>
-          </a:fillRef>
-          <a:effectRef idx="2">
-            <a:schemeClr val="accent1"/>
-          </a:effectRef>
-          <a:fontRef idx="minor">
-            <a:schemeClr val="lt1"/>
-          </a:fontRef>
-        </p:style>
-        <p:txBody>
-          <a:bodyPr rtlCol="0" anchor="ctr"/>
-          <a:lstStyle/>
-          <a:p>
-            <a:pPr algn="ctr"/>
-          </a:p>
-        </p:txBody>
-      </p:sp>
-      <p:sp>
-        <p:nvSpPr>
-          <p:cNvPr id="14" name="Rectangle 13"/>
-          <p:cNvSpPr/>
-          <p:nvPr/>
-        </p:nvSpPr>
-        <p:spPr>
-          <a:xfrm>
-            <a:off x="4937759" y="2651760"/>
-            <a:ext cx="1828800" cy="91440"/>
-          </a:xfrm>
-          <a:prstGeom prst="rect">
-            <a:avLst/>
-          </a:prstGeom>
-          <a:solidFill>
-            <a:srgbClr val="0D7AB5"/>
-          </a:solidFill>
-          <a:ln>
-            <a:noFill/>
-          </a:ln>
-        </p:spPr>
-        <p:style>
-          <a:lnRef idx="1">
-            <a:schemeClr val="accent1"/>
-          </a:lnRef>
-          <a:fillRef idx="3">
-            <a:schemeClr val="accent1"/>
-          </a:fillRef>
-          <a:effectRef idx="2">
-            <a:schemeClr val="accent1"/>
-          </a:effectRef>
-          <a:fontRef idx="minor">
-            <a:schemeClr val="lt1"/>
-          </a:fontRef>
-        </p:style>
-        <p:txBody>
-          <a:bodyPr rtlCol="0" anchor="ctr"/>
-          <a:lstStyle/>
-          <a:p>
-            <a:pPr algn="ctr"/>
-          </a:p>
-        </p:txBody>
-      </p:sp>
-      <p:sp>
-        <p:nvSpPr>
-          <p:cNvPr id="15" name="TextBox 14"/>
-          <p:cNvSpPr txBox="1"/>
-          <p:nvPr/>
-        </p:nvSpPr>
-        <p:spPr>
-          <a:xfrm>
-            <a:off x="5029199" y="1737360"/>
-            <a:ext cx="1645920" cy="274320"/>
-          </a:xfrm>
-          <a:prstGeom prst="rect">
-            <a:avLst/>
-          </a:prstGeom>
-          <a:noFill/>
-        </p:spPr>
-        <p:txBody>
-          <a:bodyPr wrap="square">
-            <a:spAutoFit/>
-          </a:bodyPr>
-          <a:lstStyle/>
-          <a:p>
-            <a:pPr algn="l">
-              <a:defRPr sz="1000" b="0">
-                <a:solidFill>
-                  <a:srgbClr val="54575E"/>
-                </a:solidFill>
-              </a:defRPr>
-            </a:pPr>
-            <a:r>
-              <a:t>Submitted</a:t>
-            </a:r>
-          </a:p>
-        </p:txBody>
-      </p:sp>
-      <p:sp>
-        <p:nvSpPr>
-          <p:cNvPr id="16" name="TextBox 15"/>
-          <p:cNvSpPr txBox="1"/>
-          <p:nvPr/>
-        </p:nvSpPr>
-        <p:spPr>
-          <a:xfrm>
-            <a:off x="5029199" y="1965960"/>
-            <a:ext cx="1645920" cy="365760"/>
-          </a:xfrm>
-          <a:prstGeom prst="rect">
-            <a:avLst/>
-          </a:prstGeom>
-          <a:noFill/>
-        </p:spPr>
-        <p:txBody>
-          <a:bodyPr wrap="square">
-            <a:spAutoFit/>
-          </a:bodyPr>
-          <a:lstStyle/>
-          <a:p>
-            <a:pPr algn="l">
-              <a:defRPr sz="2400" b="1">
-                <a:solidFill>
-                  <a:srgbClr val="172852"/>
-                </a:solidFill>
-              </a:defRPr>
-            </a:pPr>
-            <a:r>
-              <a:t>4</a:t>
-            </a:r>
-          </a:p>
-        </p:txBody>
-      </p:sp>
-      <p:sp>
-        <p:nvSpPr>
-          <p:cNvPr id="17" name="TextBox 16"/>
-          <p:cNvSpPr txBox="1"/>
-          <p:nvPr/>
-        </p:nvSpPr>
-        <p:spPr>
-          <a:xfrm>
-            <a:off x="5029199" y="2377440"/>
-            <a:ext cx="1645920" cy="274320"/>
-          </a:xfrm>
-          <a:prstGeom prst="rect">
-            <a:avLst/>
-          </a:prstGeom>
-          <a:noFill/>
-        </p:spPr>
-        <p:txBody>
-          <a:bodyPr wrap="square">
-            <a:spAutoFit/>
-          </a:bodyPr>
-          <a:lstStyle/>
-          <a:p>
-            <a:pPr algn="l">
-              <a:defRPr sz="900" b="0">
-                <a:solidFill>
-                  <a:srgbClr val="54575E"/>
-                </a:solidFill>
-              </a:defRPr>
-            </a:pPr>
-            <a:r>
-              <a:t>Awaiting response</a:t>
-            </a:r>
-          </a:p>
-        </p:txBody>
-      </p:sp>
-      <p:sp>
-        <p:nvSpPr>
-          <p:cNvPr id="18" name="Rounded Rectangle 17"/>
-          <p:cNvSpPr/>
-          <p:nvPr/>
-        </p:nvSpPr>
-        <p:spPr>
-          <a:xfrm>
-            <a:off x="7040879" y="1645920"/>
-            <a:ext cx="1828800" cy="1097280"/>
-          </a:xfrm>
-          <a:prstGeom prst="roundRect">
-            <a:avLst/>
-          </a:prstGeom>
-          <a:solidFill>
-            <a:srgbClr val="FFFFFF"/>
-          </a:solidFill>
-          <a:ln>
-            <a:solidFill>
-              <a:srgbClr val="E2E8F0"/>
-            </a:solidFill>
-          </a:ln>
-        </p:spPr>
-        <p:style>
-          <a:lnRef idx="1">
-            <a:schemeClr val="accent1"/>
-          </a:lnRef>
-          <a:fillRef idx="3">
-            <a:schemeClr val="accent1"/>
-          </a:fillRef>
-          <a:effectRef idx="2">
-            <a:schemeClr val="accent1"/>
-          </a:effectRef>
-          <a:fontRef idx="minor">
-            <a:schemeClr val="lt1"/>
-          </a:fontRef>
-        </p:style>
-        <p:txBody>
-          <a:bodyPr rtlCol="0" anchor="ctr"/>
-          <a:lstStyle/>
-          <a:p>
-            <a:pPr algn="ctr"/>
-          </a:p>
-        </p:txBody>
-      </p:sp>
-      <p:sp>
-        <p:nvSpPr>
-          <p:cNvPr id="19" name="Rectangle 18"/>
-          <p:cNvSpPr/>
-          <p:nvPr/>
-        </p:nvSpPr>
-        <p:spPr>
-          <a:xfrm>
-            <a:off x="7040879" y="2651760"/>
-            <a:ext cx="1828800" cy="91440"/>
-          </a:xfrm>
-          <a:prstGeom prst="rect">
-            <a:avLst/>
-          </a:prstGeom>
-          <a:solidFill>
-            <a:srgbClr val="E31D93"/>
-          </a:solidFill>
-          <a:ln>
-            <a:noFill/>
-          </a:ln>
-        </p:spPr>
-        <p:style>
-          <a:lnRef idx="1">
-            <a:schemeClr val="accent1"/>
-          </a:lnRef>
-          <a:fillRef idx="3">
-            <a:schemeClr val="accent1"/>
-          </a:fillRef>
-          <a:effectRef idx="2">
-            <a:schemeClr val="accent1"/>
-          </a:effectRef>
-          <a:fontRef idx="minor">
-            <a:schemeClr val="lt1"/>
-          </a:fontRef>
-        </p:style>
-        <p:txBody>
-          <a:bodyPr rtlCol="0" anchor="ctr"/>
-          <a:lstStyle/>
-          <a:p>
-            <a:pPr algn="ctr"/>
-          </a:p>
-        </p:txBody>
-      </p:sp>
-      <p:sp>
-        <p:nvSpPr>
-          <p:cNvPr id="20" name="TextBox 19"/>
-          <p:cNvSpPr txBox="1"/>
-          <p:nvPr/>
-        </p:nvSpPr>
-        <p:spPr>
-          <a:xfrm>
-            <a:off x="7132319" y="1737360"/>
-            <a:ext cx="1645920" cy="274320"/>
-          </a:xfrm>
-          <a:prstGeom prst="rect">
-            <a:avLst/>
-          </a:prstGeom>
-          <a:noFill/>
-        </p:spPr>
-        <p:txBody>
-          <a:bodyPr wrap="square">
-            <a:spAutoFit/>
-          </a:bodyPr>
-          <a:lstStyle/>
-          <a:p>
-            <a:pPr algn="l">
-              <a:defRPr sz="1000" b="0">
-                <a:solidFill>
-                  <a:srgbClr val="54575E"/>
-                </a:solidFill>
-              </a:defRPr>
-            </a:pPr>
-            <a:r>
-              <a:t>In Negotiation</a:t>
-            </a:r>
-          </a:p>
-        </p:txBody>
-      </p:sp>
-      <p:sp>
-        <p:nvSpPr>
-          <p:cNvPr id="21" name="TextBox 20"/>
-          <p:cNvSpPr txBox="1"/>
-          <p:nvPr/>
-        </p:nvSpPr>
-        <p:spPr>
-          <a:xfrm>
-            <a:off x="7132319" y="1965960"/>
-            <a:ext cx="1645920" cy="365760"/>
-          </a:xfrm>
-          <a:prstGeom prst="rect">
-            <a:avLst/>
-          </a:prstGeom>
-          <a:noFill/>
-        </p:spPr>
-        <p:txBody>
-          <a:bodyPr wrap="square">
-            <a:spAutoFit/>
-          </a:bodyPr>
-          <a:lstStyle/>
-          <a:p>
-            <a:pPr algn="l">
-              <a:defRPr sz="2400" b="1">
-                <a:solidFill>
-                  <a:srgbClr val="172852"/>
-                </a:solidFill>
-              </a:defRPr>
-            </a:pPr>
-            <a:r>
-              <a:t>1</a:t>
-            </a:r>
-          </a:p>
-        </p:txBody>
-      </p:sp>
-      <p:sp>
-        <p:nvSpPr>
-          <p:cNvPr id="22" name="TextBox 21"/>
-          <p:cNvSpPr txBox="1"/>
-          <p:nvPr/>
-        </p:nvSpPr>
-        <p:spPr>
-          <a:xfrm>
-            <a:off x="7132319" y="2377440"/>
-            <a:ext cx="1645920" cy="274320"/>
-          </a:xfrm>
-          <a:prstGeom prst="rect">
-            <a:avLst/>
-          </a:prstGeom>
-          <a:noFill/>
-        </p:spPr>
-        <p:txBody>
-          <a:bodyPr wrap="square">
-            <a:spAutoFit/>
-          </a:bodyPr>
-          <a:lstStyle/>
-          <a:p>
-            <a:pPr algn="l">
-              <a:defRPr sz="900" b="0">
-                <a:solidFill>
-                  <a:srgbClr val="54575E"/>
-                </a:solidFill>
-              </a:defRPr>
-            </a:pPr>
-            <a:r>
-              <a:t>Counter submitted</a:t>
-            </a:r>
-          </a:p>
-        </p:txBody>
-      </p:sp>
-      <p:sp>
-        <p:nvSpPr>
-          <p:cNvPr id="23" name="TextBox 22"/>
-          <p:cNvSpPr txBox="1"/>
-          <p:nvPr/>
-        </p:nvSpPr>
-        <p:spPr>
-          <a:xfrm>
-            <a:off x="457200" y="3017520"/>
-            <a:ext cx="8229600" cy="274320"/>
-          </a:xfrm>
-          <a:prstGeom prst="rect">
-            <a:avLst/>
-          </a:prstGeom>
-          <a:noFill/>
-        </p:spPr>
-        <p:txBody>
-          <a:bodyPr wrap="square">
-            <a:spAutoFit/>
-          </a:bodyPr>
-          <a:lstStyle/>
-          <a:p>
-            <a:pPr algn="l">
+            <a:pPr>
               <a:defRPr sz="1400" b="1">
                 <a:solidFill>
                   <a:srgbClr val="172852"/>
@@ -19611,15 +17878,15 @@
       </p:sp>
       <p:graphicFrame>
         <p:nvGraphicFramePr>
-          <p:cNvPr id="24" name="Table 23"/>
+          <p:cNvPr id="5" name="Table 4"/>
           <p:cNvGraphicFramePr>
             <a:graphicFrameLocks noGrp="1"/>
           </p:cNvGraphicFramePr>
           <p:nvPr/>
         </p:nvGraphicFramePr>
         <p:xfrm>
-          <a:off x="274320" y="3383280"/>
-          <a:ext cx="6675120" cy="2011680"/>
+          <a:off x="274320" y="2834640"/>
+          <a:ext cx="6217920" cy="2468879"/>
         </p:xfrm>
         <a:graphic>
           <a:graphicData uri="http://schemas.openxmlformats.org/drawingml/2006/table">
@@ -19628,24 +17895,24 @@
                 <a:tableStyleId>{5C22544A-7EE6-4342-B048-85BDC9FD1C3A}</a:tableStyleId>
               </a:tblPr>
               <a:tblGrid>
-                <a:gridCol w="1188720"/>
+                <a:gridCol w="1097280"/>
                 <a:gridCol w="1005840"/>
-                <a:gridCol w="731520"/>
+                <a:gridCol w="640080"/>
                 <a:gridCol w="548640"/>
                 <a:gridCol w="548640"/>
-                <a:gridCol w="548640"/>
+                <a:gridCol w="457200"/>
                 <a:gridCol w="548640"/>
                 <a:gridCol w="640080"/>
-                <a:gridCol w="914400"/>
+                <a:gridCol w="731520"/>
               </a:tblGrid>
-              <a:tr h="223520">
+              <a:tr h="274319">
                 <a:tc>
                   <a:txBody>
                     <a:bodyPr/>
                     <a:lstStyle/>
                     <a:p>
-                      <a:pPr>
-                        <a:defRPr sz="1000" b="1">
+                      <a:pPr algn="ctr">
+                        <a:defRPr sz="900" b="1">
                           <a:solidFill>
                             <a:srgbClr val="FFFFFF"/>
                           </a:solidFill>
@@ -19667,8 +17934,8 @@
                     <a:bodyPr/>
                     <a:lstStyle/>
                     <a:p>
-                      <a:pPr>
-                        <a:defRPr sz="1000" b="1">
+                      <a:pPr algn="ctr">
+                        <a:defRPr sz="900" b="1">
                           <a:solidFill>
                             <a:srgbClr val="FFFFFF"/>
                           </a:solidFill>
@@ -19690,8 +17957,8 @@
                     <a:bodyPr/>
                     <a:lstStyle/>
                     <a:p>
-                      <a:pPr>
-                        <a:defRPr sz="1000" b="1">
+                      <a:pPr algn="ctr">
+                        <a:defRPr sz="900" b="1">
                           <a:solidFill>
                             <a:srgbClr val="FFFFFF"/>
                           </a:solidFill>
@@ -19713,8 +17980,8 @@
                     <a:bodyPr/>
                     <a:lstStyle/>
                     <a:p>
-                      <a:pPr>
-                        <a:defRPr sz="1000" b="1">
+                      <a:pPr algn="ctr">
+                        <a:defRPr sz="900" b="1">
                           <a:solidFill>
                             <a:srgbClr val="FFFFFF"/>
                           </a:solidFill>
@@ -19736,8 +18003,8 @@
                     <a:bodyPr/>
                     <a:lstStyle/>
                     <a:p>
-                      <a:pPr>
-                        <a:defRPr sz="1000" b="1">
+                      <a:pPr algn="ctr">
+                        <a:defRPr sz="900" b="1">
                           <a:solidFill>
                             <a:srgbClr val="FFFFFF"/>
                           </a:solidFill>
@@ -19759,8 +18026,8 @@
                     <a:bodyPr/>
                     <a:lstStyle/>
                     <a:p>
-                      <a:pPr>
-                        <a:defRPr sz="1000" b="1">
+                      <a:pPr algn="ctr">
+                        <a:defRPr sz="900" b="1">
                           <a:solidFill>
                             <a:srgbClr val="FFFFFF"/>
                           </a:solidFill>
@@ -19782,8 +18049,8 @@
                     <a:bodyPr/>
                     <a:lstStyle/>
                     <a:p>
-                      <a:pPr>
-                        <a:defRPr sz="1000" b="1">
+                      <a:pPr algn="ctr">
+                        <a:defRPr sz="900" b="1">
                           <a:solidFill>
                             <a:srgbClr val="FFFFFF"/>
                           </a:solidFill>
@@ -19805,8 +18072,8 @@
                     <a:bodyPr/>
                     <a:lstStyle/>
                     <a:p>
-                      <a:pPr>
-                        <a:defRPr sz="1000" b="1">
+                      <a:pPr algn="ctr">
+                        <a:defRPr sz="900" b="1">
                           <a:solidFill>
                             <a:srgbClr val="FFFFFF"/>
                           </a:solidFill>
@@ -19828,8 +18095,8 @@
                     <a:bodyPr/>
                     <a:lstStyle/>
                     <a:p>
-                      <a:pPr>
-                        <a:defRPr sz="1000" b="1">
+                      <a:pPr algn="ctr">
+                        <a:defRPr sz="900" b="1">
                           <a:solidFill>
                             <a:srgbClr val="FFFFFF"/>
                           </a:solidFill>
@@ -19847,18 +18114,14 @@
                   </a:tcPr>
                 </a:tc>
               </a:tr>
-              <a:tr h="223520">
+              <a:tr h="274319">
                 <a:tc>
                   <a:txBody>
                     <a:bodyPr/>
                     <a:lstStyle/>
                     <a:p>
-                      <a:pPr>
-                        <a:defRPr sz="900">
-                          <a:solidFill>
-                            <a:srgbClr val="172852"/>
-                          </a:solidFill>
-                        </a:defRPr>
+                      <a:pPr algn="ctr">
+                        <a:defRPr sz="900" b="0"/>
                       </a:pPr>
                       <a:r>
                         <a:t>CVS Caremark</a:t>
@@ -19872,12 +18135,8 @@
                     <a:bodyPr/>
                     <a:lstStyle/>
                     <a:p>
-                      <a:pPr>
-                        <a:defRPr sz="900">
-                          <a:solidFill>
-                            <a:srgbClr val="172852"/>
-                          </a:solidFill>
-                        </a:defRPr>
+                      <a:pPr algn="ctr">
+                        <a:defRPr sz="900" b="0"/>
                       </a:pPr>
                       <a:r>
                         <a:t>Medicare Part D</a:t>
@@ -19891,12 +18150,8 @@
                     <a:bodyPr/>
                     <a:lstStyle/>
                     <a:p>
-                      <a:pPr>
-                        <a:defRPr sz="900">
-                          <a:solidFill>
-                            <a:srgbClr val="172852"/>
-                          </a:solidFill>
-                        </a:defRPr>
+                      <a:pPr algn="ctr">
+                        <a:defRPr sz="900" b="0"/>
                       </a:pPr>
                       <a:r>
                         <a:t>2027</a:t>
@@ -19910,12 +18165,8 @@
                     <a:bodyPr/>
                     <a:lstStyle/>
                     <a:p>
-                      <a:pPr>
-                        <a:defRPr sz="900">
-                          <a:solidFill>
-                            <a:srgbClr val="172852"/>
-                          </a:solidFill>
-                        </a:defRPr>
+                      <a:pPr algn="ctr">
+                        <a:defRPr sz="900" b="0"/>
                       </a:pPr>
                       <a:r>
                         <a:t>5.0%</a:t>
@@ -19929,12 +18180,8 @@
                     <a:bodyPr/>
                     <a:lstStyle/>
                     <a:p>
-                      <a:pPr>
-                        <a:defRPr sz="900">
-                          <a:solidFill>
-                            <a:srgbClr val="172852"/>
-                          </a:solidFill>
-                        </a:defRPr>
+                      <a:pPr algn="ctr">
+                        <a:defRPr sz="900" b="0"/>
                       </a:pPr>
                       <a:r>
                         <a:t>4.0%</a:t>
@@ -19948,12 +18195,8 @@
                     <a:bodyPr/>
                     <a:lstStyle/>
                     <a:p>
-                      <a:pPr>
-                        <a:defRPr sz="900">
-                          <a:solidFill>
-                            <a:srgbClr val="172852"/>
-                          </a:solidFill>
-                        </a:defRPr>
+                      <a:pPr algn="ctr">
+                        <a:defRPr sz="900" b="0"/>
                       </a:pPr>
                       <a:r>
                         <a:t>1.5%</a:t>
@@ -19967,12 +18210,8 @@
                     <a:bodyPr/>
                     <a:lstStyle/>
                     <a:p>
-                      <a:pPr>
-                        <a:defRPr sz="900">
-                          <a:solidFill>
-                            <a:srgbClr val="172852"/>
-                          </a:solidFill>
-                        </a:defRPr>
+                      <a:pPr algn="ctr">
+                        <a:defRPr sz="900" b="0"/>
                       </a:pPr>
                       <a:r>
                         <a:t>10.5%</a:t>
@@ -19986,12 +18225,8 @@
                     <a:bodyPr/>
                     <a:lstStyle/>
                     <a:p>
-                      <a:pPr>
-                        <a:defRPr sz="900">
-                          <a:solidFill>
-                            <a:srgbClr val="172852"/>
-                          </a:solidFill>
-                        </a:defRPr>
+                      <a:pPr algn="ctr">
+                        <a:defRPr sz="900" b="0"/>
                       </a:pPr>
                       <a:r>
                         <a:t>4.0%</a:t>
@@ -20005,12 +18240,8 @@
                     <a:bodyPr/>
                     <a:lstStyle/>
                     <a:p>
-                      <a:pPr>
-                        <a:defRPr sz="900">
-                          <a:solidFill>
-                            <a:srgbClr val="172852"/>
-                          </a:solidFill>
-                        </a:defRPr>
+                      <a:pPr algn="ctr">
+                        <a:defRPr sz="900" b="0"/>
                       </a:pPr>
                       <a:r>
                         <a:t>Submitted</a:t>
@@ -20020,18 +18251,14 @@
                   <a:tcPr/>
                 </a:tc>
               </a:tr>
-              <a:tr h="223520">
+              <a:tr h="274319">
                 <a:tc>
                   <a:txBody>
                     <a:bodyPr/>
                     <a:lstStyle/>
                     <a:p>
-                      <a:pPr>
-                        <a:defRPr sz="900">
-                          <a:solidFill>
-                            <a:srgbClr val="172852"/>
-                          </a:solidFill>
-                        </a:defRPr>
+                      <a:pPr algn="ctr">
+                        <a:defRPr sz="900" b="0"/>
                       </a:pPr>
                       <a:r>
                         <a:t>Express Scripts</a:t>
@@ -20040,7 +18267,7 @@
                   </a:txBody>
                   <a:tcPr>
                     <a:solidFill>
-                      <a:srgbClr val="DCEEF4"/>
+                      <a:srgbClr val="F0F8FF"/>
                     </a:solidFill>
                   </a:tcPr>
                 </a:tc>
@@ -20049,12 +18276,8 @@
                     <a:bodyPr/>
                     <a:lstStyle/>
                     <a:p>
-                      <a:pPr>
-                        <a:defRPr sz="900">
-                          <a:solidFill>
-                            <a:srgbClr val="172852"/>
-                          </a:solidFill>
-                        </a:defRPr>
+                      <a:pPr algn="ctr">
+                        <a:defRPr sz="900" b="0"/>
                       </a:pPr>
                       <a:r>
                         <a:t>Medicare Part D</a:t>
@@ -20063,7 +18286,7 @@
                   </a:txBody>
                   <a:tcPr>
                     <a:solidFill>
-                      <a:srgbClr val="DCEEF4"/>
+                      <a:srgbClr val="F0F8FF"/>
                     </a:solidFill>
                   </a:tcPr>
                 </a:tc>
@@ -20072,12 +18295,8 @@
                     <a:bodyPr/>
                     <a:lstStyle/>
                     <a:p>
-                      <a:pPr>
-                        <a:defRPr sz="900">
-                          <a:solidFill>
-                            <a:srgbClr val="172852"/>
-                          </a:solidFill>
-                        </a:defRPr>
+                      <a:pPr algn="ctr">
+                        <a:defRPr sz="900" b="0"/>
                       </a:pPr>
                       <a:r>
                         <a:t>2026-2027</a:t>
@@ -20086,7 +18305,7 @@
                   </a:txBody>
                   <a:tcPr>
                     <a:solidFill>
-                      <a:srgbClr val="DCEEF4"/>
+                      <a:srgbClr val="F0F8FF"/>
                     </a:solidFill>
                   </a:tcPr>
                 </a:tc>
@@ -20095,12 +18314,8 @@
                     <a:bodyPr/>
                     <a:lstStyle/>
                     <a:p>
-                      <a:pPr>
-                        <a:defRPr sz="900">
-                          <a:solidFill>
-                            <a:srgbClr val="172852"/>
-                          </a:solidFill>
-                        </a:defRPr>
+                      <a:pPr algn="ctr">
+                        <a:defRPr sz="900" b="0"/>
                       </a:pPr>
                       <a:r>
                         <a:t>5.0%</a:t>
@@ -20109,7 +18324,7 @@
                   </a:txBody>
                   <a:tcPr>
                     <a:solidFill>
-                      <a:srgbClr val="DCEEF4"/>
+                      <a:srgbClr val="F0F8FF"/>
                     </a:solidFill>
                   </a:tcPr>
                 </a:tc>
@@ -20118,12 +18333,8 @@
                     <a:bodyPr/>
                     <a:lstStyle/>
                     <a:p>
-                      <a:pPr>
-                        <a:defRPr sz="900">
-                          <a:solidFill>
-                            <a:srgbClr val="172852"/>
-                          </a:solidFill>
-                        </a:defRPr>
+                      <a:pPr algn="ctr">
+                        <a:defRPr sz="900" b="0"/>
                       </a:pPr>
                       <a:r>
                         <a:t>5.0%</a:t>
@@ -20132,7 +18343,7 @@
                   </a:txBody>
                   <a:tcPr>
                     <a:solidFill>
-                      <a:srgbClr val="DCEEF4"/>
+                      <a:srgbClr val="F0F8FF"/>
                     </a:solidFill>
                   </a:tcPr>
                 </a:tc>
@@ -20141,12 +18352,8 @@
                     <a:bodyPr/>
                     <a:lstStyle/>
                     <a:p>
-                      <a:pPr>
-                        <a:defRPr sz="900">
-                          <a:solidFill>
-                            <a:srgbClr val="172852"/>
-                          </a:solidFill>
-                        </a:defRPr>
+                      <a:pPr algn="ctr">
+                        <a:defRPr sz="900" b="0"/>
                       </a:pPr>
                       <a:r>
                         <a:t>0.0%</a:t>
@@ -20155,7 +18362,7 @@
                   </a:txBody>
                   <a:tcPr>
                     <a:solidFill>
-                      <a:srgbClr val="DCEEF4"/>
+                      <a:srgbClr val="F0F8FF"/>
                     </a:solidFill>
                   </a:tcPr>
                 </a:tc>
@@ -20164,12 +18371,8 @@
                     <a:bodyPr/>
                     <a:lstStyle/>
                     <a:p>
-                      <a:pPr>
-                        <a:defRPr sz="900">
-                          <a:solidFill>
-                            <a:srgbClr val="172852"/>
-                          </a:solidFill>
-                        </a:defRPr>
+                      <a:pPr algn="ctr">
+                        <a:defRPr sz="900" b="0"/>
                       </a:pPr>
                       <a:r>
                         <a:t>10.0%</a:t>
@@ -20178,7 +18381,7 @@
                   </a:txBody>
                   <a:tcPr>
                     <a:solidFill>
-                      <a:srgbClr val="DCEEF4"/>
+                      <a:srgbClr val="F0F8FF"/>
                     </a:solidFill>
                   </a:tcPr>
                 </a:tc>
@@ -20187,12 +18390,8 @@
                     <a:bodyPr/>
                     <a:lstStyle/>
                     <a:p>
-                      <a:pPr>
-                        <a:defRPr sz="900">
-                          <a:solidFill>
-                            <a:srgbClr val="172852"/>
-                          </a:solidFill>
-                        </a:defRPr>
+                      <a:pPr algn="ctr">
+                        <a:defRPr sz="900" b="0"/>
                       </a:pPr>
                       <a:r>
                         <a:t>5.0%</a:t>
@@ -20201,7 +18400,7 @@
                   </a:txBody>
                   <a:tcPr>
                     <a:solidFill>
-                      <a:srgbClr val="DCEEF4"/>
+                      <a:srgbClr val="F0F8FF"/>
                     </a:solidFill>
                   </a:tcPr>
                 </a:tc>
@@ -20210,12 +18409,8 @@
                     <a:bodyPr/>
                     <a:lstStyle/>
                     <a:p>
-                      <a:pPr>
-                        <a:defRPr sz="900">
-                          <a:solidFill>
-                            <a:srgbClr val="172852"/>
-                          </a:solidFill>
-                        </a:defRPr>
+                      <a:pPr algn="ctr">
+                        <a:defRPr sz="900" b="0"/>
                       </a:pPr>
                       <a:r>
                         <a:t>Signed</a:t>
@@ -20224,23 +18419,19 @@
                   </a:txBody>
                   <a:tcPr>
                     <a:solidFill>
-                      <a:srgbClr val="DCEEF4"/>
+                      <a:srgbClr val="F0F8FF"/>
                     </a:solidFill>
                   </a:tcPr>
                 </a:tc>
               </a:tr>
-              <a:tr h="223520">
+              <a:tr h="274319">
                 <a:tc>
                   <a:txBody>
                     <a:bodyPr/>
                     <a:lstStyle/>
                     <a:p>
-                      <a:pPr>
-                        <a:defRPr sz="900">
-                          <a:solidFill>
-                            <a:srgbClr val="172852"/>
-                          </a:solidFill>
-                        </a:defRPr>
+                      <a:pPr algn="ctr">
+                        <a:defRPr sz="900" b="0"/>
                       </a:pPr>
                       <a:r>
                         <a:t>OptumRx</a:t>
@@ -20254,12 +18445,8 @@
                     <a:bodyPr/>
                     <a:lstStyle/>
                     <a:p>
-                      <a:pPr>
-                        <a:defRPr sz="900">
-                          <a:solidFill>
-                            <a:srgbClr val="172852"/>
-                          </a:solidFill>
-                        </a:defRPr>
+                      <a:pPr algn="ctr">
+                        <a:defRPr sz="900" b="0"/>
                       </a:pPr>
                       <a:r>
                         <a:t>Medicare Part D</a:t>
@@ -20273,12 +18460,8 @@
                     <a:bodyPr/>
                     <a:lstStyle/>
                     <a:p>
-                      <a:pPr>
-                        <a:defRPr sz="900">
-                          <a:solidFill>
-                            <a:srgbClr val="172852"/>
-                          </a:solidFill>
-                        </a:defRPr>
+                      <a:pPr algn="ctr">
+                        <a:defRPr sz="900" b="0"/>
                       </a:pPr>
                       <a:r>
                         <a:t>2026</a:t>
@@ -20292,12 +18475,8 @@
                     <a:bodyPr/>
                     <a:lstStyle/>
                     <a:p>
-                      <a:pPr>
-                        <a:defRPr sz="900">
-                          <a:solidFill>
-                            <a:srgbClr val="172852"/>
-                          </a:solidFill>
-                        </a:defRPr>
+                      <a:pPr algn="ctr">
+                        <a:defRPr sz="900" b="0"/>
                       </a:pPr>
                       <a:r>
                         <a:t>5.0%</a:t>
@@ -20311,12 +18490,8 @@
                     <a:bodyPr/>
                     <a:lstStyle/>
                     <a:p>
-                      <a:pPr>
-                        <a:defRPr sz="900">
-                          <a:solidFill>
-                            <a:srgbClr val="172852"/>
-                          </a:solidFill>
-                        </a:defRPr>
+                      <a:pPr algn="ctr">
+                        <a:defRPr sz="900" b="0"/>
                       </a:pPr>
                       <a:r>
                         <a:t>5.0%</a:t>
@@ -20330,12 +18505,8 @@
                     <a:bodyPr/>
                     <a:lstStyle/>
                     <a:p>
-                      <a:pPr>
-                        <a:defRPr sz="900">
-                          <a:solidFill>
-                            <a:srgbClr val="172852"/>
-                          </a:solidFill>
-                        </a:defRPr>
+                      <a:pPr algn="ctr">
+                        <a:defRPr sz="900" b="0"/>
                       </a:pPr>
                       <a:r>
                         <a:t>0.0%</a:t>
@@ -20349,12 +18520,8 @@
                     <a:bodyPr/>
                     <a:lstStyle/>
                     <a:p>
-                      <a:pPr>
-                        <a:defRPr sz="900">
-                          <a:solidFill>
-                            <a:srgbClr val="172852"/>
-                          </a:solidFill>
-                        </a:defRPr>
+                      <a:pPr algn="ctr">
+                        <a:defRPr sz="900" b="0"/>
                       </a:pPr>
                       <a:r>
                         <a:t>10.0%</a:t>
@@ -20368,12 +18535,8 @@
                     <a:bodyPr/>
                     <a:lstStyle/>
                     <a:p>
-                      <a:pPr>
-                        <a:defRPr sz="900">
-                          <a:solidFill>
-                            <a:srgbClr val="172852"/>
-                          </a:solidFill>
-                        </a:defRPr>
+                      <a:pPr algn="ctr">
+                        <a:defRPr sz="900" b="0"/>
                       </a:pPr>
                       <a:r>
                         <a:t>5.0%</a:t>
@@ -20387,12 +18550,8 @@
                     <a:bodyPr/>
                     <a:lstStyle/>
                     <a:p>
-                      <a:pPr>
-                        <a:defRPr sz="900">
-                          <a:solidFill>
-                            <a:srgbClr val="172852"/>
-                          </a:solidFill>
-                        </a:defRPr>
+                      <a:pPr algn="ctr">
+                        <a:defRPr sz="900" b="0"/>
                       </a:pPr>
                       <a:r>
                         <a:t>Submitted</a:t>
@@ -20402,18 +18561,14 @@
                   <a:tcPr/>
                 </a:tc>
               </a:tr>
-              <a:tr h="223520">
+              <a:tr h="274319">
                 <a:tc>
                   <a:txBody>
                     <a:bodyPr/>
                     <a:lstStyle/>
                     <a:p>
-                      <a:pPr>
-                        <a:defRPr sz="900">
-                          <a:solidFill>
-                            <a:srgbClr val="172852"/>
-                          </a:solidFill>
-                        </a:defRPr>
+                      <a:pPr algn="ctr">
+                        <a:defRPr sz="900" b="0"/>
                       </a:pPr>
                       <a:r>
                         <a:t>Humana</a:t>
@@ -20422,7 +18577,7 @@
                   </a:txBody>
                   <a:tcPr>
                     <a:solidFill>
-                      <a:srgbClr val="DCEEF4"/>
+                      <a:srgbClr val="F0F8FF"/>
                     </a:solidFill>
                   </a:tcPr>
                 </a:tc>
@@ -20431,12 +18586,8 @@
                     <a:bodyPr/>
                     <a:lstStyle/>
                     <a:p>
-                      <a:pPr>
-                        <a:defRPr sz="900">
-                          <a:solidFill>
-                            <a:srgbClr val="172852"/>
-                          </a:solidFill>
-                        </a:defRPr>
+                      <a:pPr algn="ctr">
+                        <a:defRPr sz="900" b="0"/>
                       </a:pPr>
                       <a:r>
                         <a:t>Medicare Part D</a:t>
@@ -20445,7 +18596,7 @@
                   </a:txBody>
                   <a:tcPr>
                     <a:solidFill>
-                      <a:srgbClr val="DCEEF4"/>
+                      <a:srgbClr val="F0F8FF"/>
                     </a:solidFill>
                   </a:tcPr>
                 </a:tc>
@@ -20454,12 +18605,8 @@
                     <a:bodyPr/>
                     <a:lstStyle/>
                     <a:p>
-                      <a:pPr>
-                        <a:defRPr sz="900">
-                          <a:solidFill>
-                            <a:srgbClr val="172852"/>
-                          </a:solidFill>
-                        </a:defRPr>
+                      <a:pPr algn="ctr">
+                        <a:defRPr sz="900" b="0"/>
                       </a:pPr>
                       <a:r>
                         <a:t>2027</a:t>
@@ -20468,7 +18615,7 @@
                   </a:txBody>
                   <a:tcPr>
                     <a:solidFill>
-                      <a:srgbClr val="DCEEF4"/>
+                      <a:srgbClr val="F0F8FF"/>
                     </a:solidFill>
                   </a:tcPr>
                 </a:tc>
@@ -20477,12 +18624,8 @@
                     <a:bodyPr/>
                     <a:lstStyle/>
                     <a:p>
-                      <a:pPr>
-                        <a:defRPr sz="900">
-                          <a:solidFill>
-                            <a:srgbClr val="172852"/>
-                          </a:solidFill>
-                        </a:defRPr>
+                      <a:pPr algn="ctr">
+                        <a:defRPr sz="900" b="0"/>
                       </a:pPr>
                       <a:r>
                         <a:t>15.0%</a:t>
@@ -20491,7 +18634,7 @@
                   </a:txBody>
                   <a:tcPr>
                     <a:solidFill>
-                      <a:srgbClr val="DCEEF4"/>
+                      <a:srgbClr val="F0F8FF"/>
                     </a:solidFill>
                   </a:tcPr>
                 </a:tc>
@@ -20500,12 +18643,8 @@
                     <a:bodyPr/>
                     <a:lstStyle/>
                     <a:p>
-                      <a:pPr>
-                        <a:defRPr sz="900">
-                          <a:solidFill>
-                            <a:srgbClr val="172852"/>
-                          </a:solidFill>
-                        </a:defRPr>
+                      <a:pPr algn="ctr">
+                        <a:defRPr sz="900" b="0"/>
                       </a:pPr>
                       <a:r>
                         <a:t>0.0%</a:t>
@@ -20514,7 +18653,7 @@
                   </a:txBody>
                   <a:tcPr>
                     <a:solidFill>
-                      <a:srgbClr val="DCEEF4"/>
+                      <a:srgbClr val="F0F8FF"/>
                     </a:solidFill>
                   </a:tcPr>
                 </a:tc>
@@ -20523,12 +18662,8 @@
                     <a:bodyPr/>
                     <a:lstStyle/>
                     <a:p>
-                      <a:pPr>
-                        <a:defRPr sz="900">
-                          <a:solidFill>
-                            <a:srgbClr val="172852"/>
-                          </a:solidFill>
-                        </a:defRPr>
+                      <a:pPr algn="ctr">
+                        <a:defRPr sz="900" b="0"/>
                       </a:pPr>
                       <a:r>
                         <a:t>0.0%</a:t>
@@ -20537,7 +18672,7 @@
                   </a:txBody>
                   <a:tcPr>
                     <a:solidFill>
-                      <a:srgbClr val="DCEEF4"/>
+                      <a:srgbClr val="F0F8FF"/>
                     </a:solidFill>
                   </a:tcPr>
                 </a:tc>
@@ -20546,12 +18681,8 @@
                     <a:bodyPr/>
                     <a:lstStyle/>
                     <a:p>
-                      <a:pPr>
-                        <a:defRPr sz="900">
-                          <a:solidFill>
-                            <a:srgbClr val="172852"/>
-                          </a:solidFill>
-                        </a:defRPr>
+                      <a:pPr algn="ctr">
+                        <a:defRPr sz="900" b="0"/>
                       </a:pPr>
                       <a:r>
                         <a:t>15.0%</a:t>
@@ -20560,7 +18691,7 @@
                   </a:txBody>
                   <a:tcPr>
                     <a:solidFill>
-                      <a:srgbClr val="DCEEF4"/>
+                      <a:srgbClr val="F0F8FF"/>
                     </a:solidFill>
                   </a:tcPr>
                 </a:tc>
@@ -20569,12 +18700,8 @@
                     <a:bodyPr/>
                     <a:lstStyle/>
                     <a:p>
-                      <a:pPr>
-                        <a:defRPr sz="900">
-                          <a:solidFill>
-                            <a:srgbClr val="172852"/>
-                          </a:solidFill>
-                        </a:defRPr>
+                      <a:pPr algn="ctr">
+                        <a:defRPr sz="900" b="0"/>
                       </a:pPr>
                       <a:r>
                         <a:t>5.0%</a:t>
@@ -20583,7 +18710,7 @@
                   </a:txBody>
                   <a:tcPr>
                     <a:solidFill>
-                      <a:srgbClr val="DCEEF4"/>
+                      <a:srgbClr val="F0F8FF"/>
                     </a:solidFill>
                   </a:tcPr>
                 </a:tc>
@@ -20592,12 +18719,8 @@
                     <a:bodyPr/>
                     <a:lstStyle/>
                     <a:p>
-                      <a:pPr>
-                        <a:defRPr sz="900">
-                          <a:solidFill>
-                            <a:srgbClr val="172852"/>
-                          </a:solidFill>
-                        </a:defRPr>
+                      <a:pPr algn="ctr">
+                        <a:defRPr sz="900" b="0"/>
                       </a:pPr>
                       <a:r>
                         <a:t>Submitted</a:t>
@@ -20606,23 +18729,19 @@
                   </a:txBody>
                   <a:tcPr>
                     <a:solidFill>
-                      <a:srgbClr val="DCEEF4"/>
+                      <a:srgbClr val="F0F8FF"/>
                     </a:solidFill>
                   </a:tcPr>
                 </a:tc>
               </a:tr>
-              <a:tr h="223520">
+              <a:tr h="274319">
                 <a:tc>
                   <a:txBody>
                     <a:bodyPr/>
                     <a:lstStyle/>
                     <a:p>
-                      <a:pPr>
-                        <a:defRPr sz="900">
-                          <a:solidFill>
-                            <a:srgbClr val="172852"/>
-                          </a:solidFill>
-                        </a:defRPr>
+                      <a:pPr algn="ctr">
+                        <a:defRPr sz="900" b="0"/>
                       </a:pPr>
                       <a:r>
                         <a:t>Express Scripts</a:t>
@@ -20636,12 +18755,8 @@
                     <a:bodyPr/>
                     <a:lstStyle/>
                     <a:p>
-                      <a:pPr>
-                        <a:defRPr sz="900">
-                          <a:solidFill>
-                            <a:srgbClr val="172852"/>
-                          </a:solidFill>
-                        </a:defRPr>
+                      <a:pPr algn="ctr">
+                        <a:defRPr sz="900" b="0"/>
                       </a:pPr>
                       <a:r>
                         <a:t>Government</a:t>
@@ -20655,12 +18770,8 @@
                     <a:bodyPr/>
                     <a:lstStyle/>
                     <a:p>
-                      <a:pPr>
-                        <a:defRPr sz="900">
-                          <a:solidFill>
-                            <a:srgbClr val="172852"/>
-                          </a:solidFill>
-                        </a:defRPr>
+                      <a:pPr algn="ctr">
+                        <a:defRPr sz="900" b="0"/>
                       </a:pPr>
                       <a:r>
                         <a:t>2026-2027</a:t>
@@ -20674,12 +18785,8 @@
                     <a:bodyPr/>
                     <a:lstStyle/>
                     <a:p>
-                      <a:pPr>
-                        <a:defRPr sz="900">
-                          <a:solidFill>
-                            <a:srgbClr val="172852"/>
-                          </a:solidFill>
-                        </a:defRPr>
+                      <a:pPr algn="ctr">
+                        <a:defRPr sz="900" b="0"/>
                       </a:pPr>
                       <a:r>
                         <a:t>5.0%</a:t>
@@ -20693,12 +18800,8 @@
                     <a:bodyPr/>
                     <a:lstStyle/>
                     <a:p>
-                      <a:pPr>
-                        <a:defRPr sz="900">
-                          <a:solidFill>
-                            <a:srgbClr val="172852"/>
-                          </a:solidFill>
-                        </a:defRPr>
+                      <a:pPr algn="ctr">
+                        <a:defRPr sz="900" b="0"/>
                       </a:pPr>
                       <a:r>
                         <a:t>5.0%</a:t>
@@ -20712,12 +18815,8 @@
                     <a:bodyPr/>
                     <a:lstStyle/>
                     <a:p>
-                      <a:pPr>
-                        <a:defRPr sz="900">
-                          <a:solidFill>
-                            <a:srgbClr val="172852"/>
-                          </a:solidFill>
-                        </a:defRPr>
+                      <a:pPr algn="ctr">
+                        <a:defRPr sz="900" b="0"/>
                       </a:pPr>
                       <a:r>
                         <a:t>0.0%</a:t>
@@ -20731,12 +18830,8 @@
                     <a:bodyPr/>
                     <a:lstStyle/>
                     <a:p>
-                      <a:pPr>
-                        <a:defRPr sz="900">
-                          <a:solidFill>
-                            <a:srgbClr val="172852"/>
-                          </a:solidFill>
-                        </a:defRPr>
+                      <a:pPr algn="ctr">
+                        <a:defRPr sz="900" b="0"/>
                       </a:pPr>
                       <a:r>
                         <a:t>10.0%</a:t>
@@ -20750,12 +18845,8 @@
                     <a:bodyPr/>
                     <a:lstStyle/>
                     <a:p>
-                      <a:pPr>
-                        <a:defRPr sz="900">
-                          <a:solidFill>
-                            <a:srgbClr val="172852"/>
-                          </a:solidFill>
-                        </a:defRPr>
+                      <a:pPr algn="ctr">
+                        <a:defRPr sz="900" b="0"/>
                       </a:pPr>
                       <a:r>
                         <a:t>—</a:t>
@@ -20769,12 +18860,8 @@
                     <a:bodyPr/>
                     <a:lstStyle/>
                     <a:p>
-                      <a:pPr>
-                        <a:defRPr sz="900">
-                          <a:solidFill>
-                            <a:srgbClr val="172852"/>
-                          </a:solidFill>
-                        </a:defRPr>
+                      <a:pPr algn="ctr">
+                        <a:defRPr sz="900" b="0"/>
                       </a:pPr>
                       <a:r>
                         <a:t>Signed</a:t>
@@ -20784,18 +18871,14 @@
                   <a:tcPr/>
                 </a:tc>
               </a:tr>
-              <a:tr h="223520">
+              <a:tr h="274319">
                 <a:tc>
                   <a:txBody>
                     <a:bodyPr/>
                     <a:lstStyle/>
                     <a:p>
-                      <a:pPr>
-                        <a:defRPr sz="900">
-                          <a:solidFill>
-                            <a:srgbClr val="172852"/>
-                          </a:solidFill>
-                        </a:defRPr>
+                      <a:pPr algn="ctr">
+                        <a:defRPr sz="900" b="0"/>
                       </a:pPr>
                       <a:r>
                         <a:t>Ascent Health</a:t>
@@ -20804,7 +18887,7 @@
                   </a:txBody>
                   <a:tcPr>
                     <a:solidFill>
-                      <a:srgbClr val="DCEEF4"/>
+                      <a:srgbClr val="F0F8FF"/>
                     </a:solidFill>
                   </a:tcPr>
                 </a:tc>
@@ -20813,12 +18896,8 @@
                     <a:bodyPr/>
                     <a:lstStyle/>
                     <a:p>
-                      <a:pPr>
-                        <a:defRPr sz="900">
-                          <a:solidFill>
-                            <a:srgbClr val="172852"/>
-                          </a:solidFill>
-                        </a:defRPr>
+                      <a:pPr algn="ctr">
+                        <a:defRPr sz="900" b="0"/>
                       </a:pPr>
                       <a:r>
                         <a:t>Commercial</a:t>
@@ -20827,7 +18906,7 @@
                   </a:txBody>
                   <a:tcPr>
                     <a:solidFill>
-                      <a:srgbClr val="DCEEF4"/>
+                      <a:srgbClr val="F0F8FF"/>
                     </a:solidFill>
                   </a:tcPr>
                 </a:tc>
@@ -20836,12 +18915,8 @@
                     <a:bodyPr/>
                     <a:lstStyle/>
                     <a:p>
-                      <a:pPr>
-                        <a:defRPr sz="900">
-                          <a:solidFill>
-                            <a:srgbClr val="172852"/>
-                          </a:solidFill>
-                        </a:defRPr>
+                      <a:pPr algn="ctr">
+                        <a:defRPr sz="900" b="0"/>
                       </a:pPr>
                       <a:r>
                         <a:t>2026-2027</a:t>
@@ -20850,7 +18925,7 @@
                   </a:txBody>
                   <a:tcPr>
                     <a:solidFill>
-                      <a:srgbClr val="DCEEF4"/>
+                      <a:srgbClr val="F0F8FF"/>
                     </a:solidFill>
                   </a:tcPr>
                 </a:tc>
@@ -20859,12 +18934,8 @@
                     <a:bodyPr/>
                     <a:lstStyle/>
                     <a:p>
-                      <a:pPr>
-                        <a:defRPr sz="900">
-                          <a:solidFill>
-                            <a:srgbClr val="172852"/>
-                          </a:solidFill>
-                        </a:defRPr>
+                      <a:pPr algn="ctr">
+                        <a:defRPr sz="900" b="0"/>
                       </a:pPr>
                       <a:r>
                         <a:t>4.0%</a:t>
@@ -20873,7 +18944,7 @@
                   </a:txBody>
                   <a:tcPr>
                     <a:solidFill>
-                      <a:srgbClr val="DCEEF4"/>
+                      <a:srgbClr val="F0F8FF"/>
                     </a:solidFill>
                   </a:tcPr>
                 </a:tc>
@@ -20882,12 +18953,8 @@
                     <a:bodyPr/>
                     <a:lstStyle/>
                     <a:p>
-                      <a:pPr>
-                        <a:defRPr sz="900">
-                          <a:solidFill>
-                            <a:srgbClr val="172852"/>
-                          </a:solidFill>
-                        </a:defRPr>
+                      <a:pPr algn="ctr">
+                        <a:defRPr sz="900" b="0"/>
                       </a:pPr>
                       <a:r>
                         <a:t>3.0%</a:t>
@@ -20896,7 +18963,7 @@
                   </a:txBody>
                   <a:tcPr>
                     <a:solidFill>
-                      <a:srgbClr val="DCEEF4"/>
+                      <a:srgbClr val="F0F8FF"/>
                     </a:solidFill>
                   </a:tcPr>
                 </a:tc>
@@ -20905,12 +18972,8 @@
                     <a:bodyPr/>
                     <a:lstStyle/>
                     <a:p>
-                      <a:pPr>
-                        <a:defRPr sz="900">
-                          <a:solidFill>
-                            <a:srgbClr val="172852"/>
-                          </a:solidFill>
-                        </a:defRPr>
+                      <a:pPr algn="ctr">
+                        <a:defRPr sz="900" b="0"/>
                       </a:pPr>
                       <a:r>
                         <a:t>2.5%</a:t>
@@ -20919,7 +18982,7 @@
                   </a:txBody>
                   <a:tcPr>
                     <a:solidFill>
-                      <a:srgbClr val="DCEEF4"/>
+                      <a:srgbClr val="F0F8FF"/>
                     </a:solidFill>
                   </a:tcPr>
                 </a:tc>
@@ -20928,12 +18991,8 @@
                     <a:bodyPr/>
                     <a:lstStyle/>
                     <a:p>
-                      <a:pPr>
-                        <a:defRPr sz="900">
-                          <a:solidFill>
-                            <a:srgbClr val="172852"/>
-                          </a:solidFill>
-                        </a:defRPr>
+                      <a:pPr algn="ctr">
+                        <a:defRPr sz="900" b="0"/>
                       </a:pPr>
                       <a:r>
                         <a:t>9.5%</a:t>
@@ -20942,7 +19001,7 @@
                   </a:txBody>
                   <a:tcPr>
                     <a:solidFill>
-                      <a:srgbClr val="DCEEF4"/>
+                      <a:srgbClr val="F0F8FF"/>
                     </a:solidFill>
                   </a:tcPr>
                 </a:tc>
@@ -20951,12 +19010,8 @@
                     <a:bodyPr/>
                     <a:lstStyle/>
                     <a:p>
-                      <a:pPr>
-                        <a:defRPr sz="900">
-                          <a:solidFill>
-                            <a:srgbClr val="172852"/>
-                          </a:solidFill>
-                        </a:defRPr>
+                      <a:pPr algn="ctr">
+                        <a:defRPr sz="900" b="0"/>
                       </a:pPr>
                       <a:r>
                         <a:t>4.0%</a:t>
@@ -20965,7 +19020,7 @@
                   </a:txBody>
                   <a:tcPr>
                     <a:solidFill>
-                      <a:srgbClr val="DCEEF4"/>
+                      <a:srgbClr val="F0F8FF"/>
                     </a:solidFill>
                   </a:tcPr>
                 </a:tc>
@@ -20974,12 +19029,8 @@
                     <a:bodyPr/>
                     <a:lstStyle/>
                     <a:p>
-                      <a:pPr>
-                        <a:defRPr sz="900">
-                          <a:solidFill>
-                            <a:srgbClr val="172852"/>
-                          </a:solidFill>
-                        </a:defRPr>
+                      <a:pPr algn="ctr">
+                        <a:defRPr sz="900" b="0"/>
                       </a:pPr>
                       <a:r>
                         <a:t>Signed</a:t>
@@ -20988,23 +19039,19 @@
                   </a:txBody>
                   <a:tcPr>
                     <a:solidFill>
-                      <a:srgbClr val="DCEEF4"/>
+                      <a:srgbClr val="F0F8FF"/>
                     </a:solidFill>
                   </a:tcPr>
                 </a:tc>
               </a:tr>
-              <a:tr h="223520">
+              <a:tr h="274319">
                 <a:tc>
                   <a:txBody>
                     <a:bodyPr/>
                     <a:lstStyle/>
                     <a:p>
-                      <a:pPr>
-                        <a:defRPr sz="900">
-                          <a:solidFill>
-                            <a:srgbClr val="172852"/>
-                          </a:solidFill>
-                        </a:defRPr>
+                      <a:pPr algn="ctr">
+                        <a:defRPr sz="900" b="0"/>
                       </a:pPr>
                       <a:r>
                         <a:t>Emisar</a:t>
@@ -21018,12 +19065,8 @@
                     <a:bodyPr/>
                     <a:lstStyle/>
                     <a:p>
-                      <a:pPr>
-                        <a:defRPr sz="900">
-                          <a:solidFill>
-                            <a:srgbClr val="172852"/>
-                          </a:solidFill>
-                        </a:defRPr>
+                      <a:pPr algn="ctr">
+                        <a:defRPr sz="900" b="0"/>
                       </a:pPr>
                       <a:r>
                         <a:t>Commercial</a:t>
@@ -21037,12 +19080,8 @@
                     <a:bodyPr/>
                     <a:lstStyle/>
                     <a:p>
-                      <a:pPr>
-                        <a:defRPr sz="900">
-                          <a:solidFill>
-                            <a:srgbClr val="172852"/>
-                          </a:solidFill>
-                        </a:defRPr>
+                      <a:pPr algn="ctr">
+                        <a:defRPr sz="900" b="0"/>
                       </a:pPr>
                       <a:r>
                         <a:t>2026-2027</a:t>
@@ -21056,12 +19095,8 @@
                     <a:bodyPr/>
                     <a:lstStyle/>
                     <a:p>
-                      <a:pPr>
-                        <a:defRPr sz="900">
-                          <a:solidFill>
-                            <a:srgbClr val="172852"/>
-                          </a:solidFill>
-                        </a:defRPr>
+                      <a:pPr algn="ctr">
+                        <a:defRPr sz="900" b="0"/>
                       </a:pPr>
                       <a:r>
                         <a:t>10.0%</a:t>
@@ -21075,12 +19110,8 @@
                     <a:bodyPr/>
                     <a:lstStyle/>
                     <a:p>
-                      <a:pPr>
-                        <a:defRPr sz="900">
-                          <a:solidFill>
-                            <a:srgbClr val="172852"/>
-                          </a:solidFill>
-                        </a:defRPr>
+                      <a:pPr algn="ctr">
+                        <a:defRPr sz="900" b="0"/>
                       </a:pPr>
                       <a:r>
                         <a:t>5.0%</a:t>
@@ -21094,12 +19125,8 @@
                     <a:bodyPr/>
                     <a:lstStyle/>
                     <a:p>
-                      <a:pPr>
-                        <a:defRPr sz="900">
-                          <a:solidFill>
-                            <a:srgbClr val="172852"/>
-                          </a:solidFill>
-                        </a:defRPr>
+                      <a:pPr algn="ctr">
+                        <a:defRPr sz="900" b="0"/>
                       </a:pPr>
                       <a:r>
                         <a:t>0.0%</a:t>
@@ -21113,12 +19140,8 @@
                     <a:bodyPr/>
                     <a:lstStyle/>
                     <a:p>
-                      <a:pPr>
-                        <a:defRPr sz="900">
-                          <a:solidFill>
-                            <a:srgbClr val="172852"/>
-                          </a:solidFill>
-                        </a:defRPr>
+                      <a:pPr algn="ctr">
+                        <a:defRPr sz="900" b="0"/>
                       </a:pPr>
                       <a:r>
                         <a:t>15.0%</a:t>
@@ -21132,12 +19155,8 @@
                     <a:bodyPr/>
                     <a:lstStyle/>
                     <a:p>
-                      <a:pPr>
-                        <a:defRPr sz="900">
-                          <a:solidFill>
-                            <a:srgbClr val="172852"/>
-                          </a:solidFill>
-                        </a:defRPr>
+                      <a:pPr algn="ctr">
+                        <a:defRPr sz="900" b="0"/>
                       </a:pPr>
                       <a:r>
                         <a:t>5.0%</a:t>
@@ -21151,33 +19170,25 @@
                     <a:bodyPr/>
                     <a:lstStyle/>
                     <a:p>
-                      <a:pPr>
-                        <a:defRPr sz="900">
-                          <a:solidFill>
-                            <a:srgbClr val="172852"/>
-                          </a:solidFill>
-                        </a:defRPr>
+                      <a:pPr algn="ctr">
+                        <a:defRPr sz="900" b="0"/>
                       </a:pPr>
                       <a:r>
-                        <a:t>Counter Submitted</a:t>
+                        <a:t>Counter</a:t>
                       </a:r>
                     </a:p>
                   </a:txBody>
                   <a:tcPr/>
                 </a:tc>
               </a:tr>
-              <a:tr h="223520">
+              <a:tr h="274327">
                 <a:tc>
                   <a:txBody>
                     <a:bodyPr/>
                     <a:lstStyle/>
                     <a:p>
-                      <a:pPr>
-                        <a:defRPr sz="900">
-                          <a:solidFill>
-                            <a:srgbClr val="172852"/>
-                          </a:solidFill>
-                        </a:defRPr>
+                      <a:pPr algn="ctr">
+                        <a:defRPr sz="900" b="0"/>
                       </a:pPr>
                       <a:r>
                         <a:t>Zinc Health</a:t>
@@ -21186,7 +19197,7 @@
                   </a:txBody>
                   <a:tcPr>
                     <a:solidFill>
-                      <a:srgbClr val="DCEEF4"/>
+                      <a:srgbClr val="F0F8FF"/>
                     </a:solidFill>
                   </a:tcPr>
                 </a:tc>
@@ -21195,12 +19206,8 @@
                     <a:bodyPr/>
                     <a:lstStyle/>
                     <a:p>
-                      <a:pPr>
-                        <a:defRPr sz="900">
-                          <a:solidFill>
-                            <a:srgbClr val="172852"/>
-                          </a:solidFill>
-                        </a:defRPr>
+                      <a:pPr algn="ctr">
+                        <a:defRPr sz="900" b="0"/>
                       </a:pPr>
                       <a:r>
                         <a:t>Commercial</a:t>
@@ -21209,7 +19216,7 @@
                   </a:txBody>
                   <a:tcPr>
                     <a:solidFill>
-                      <a:srgbClr val="DCEEF4"/>
+                      <a:srgbClr val="F0F8FF"/>
                     </a:solidFill>
                   </a:tcPr>
                 </a:tc>
@@ -21218,12 +19225,8 @@
                     <a:bodyPr/>
                     <a:lstStyle/>
                     <a:p>
-                      <a:pPr>
-                        <a:defRPr sz="900">
-                          <a:solidFill>
-                            <a:srgbClr val="172852"/>
-                          </a:solidFill>
-                        </a:defRPr>
+                      <a:pPr algn="ctr">
+                        <a:defRPr sz="900" b="0"/>
                       </a:pPr>
                       <a:r>
                         <a:t>2026-2027</a:t>
@@ -21232,7 +19235,7 @@
                   </a:txBody>
                   <a:tcPr>
                     <a:solidFill>
-                      <a:srgbClr val="DCEEF4"/>
+                      <a:srgbClr val="F0F8FF"/>
                     </a:solidFill>
                   </a:tcPr>
                 </a:tc>
@@ -21241,12 +19244,8 @@
                     <a:bodyPr/>
                     <a:lstStyle/>
                     <a:p>
-                      <a:pPr>
-                        <a:defRPr sz="900">
-                          <a:solidFill>
-                            <a:srgbClr val="172852"/>
-                          </a:solidFill>
-                        </a:defRPr>
+                      <a:pPr algn="ctr">
+                        <a:defRPr sz="900" b="0"/>
                       </a:pPr>
                       <a:r>
                         <a:t>4.5%</a:t>
@@ -21255,7 +19254,7 @@
                   </a:txBody>
                   <a:tcPr>
                     <a:solidFill>
-                      <a:srgbClr val="DCEEF4"/>
+                      <a:srgbClr val="F0F8FF"/>
                     </a:solidFill>
                   </a:tcPr>
                 </a:tc>
@@ -21264,12 +19263,8 @@
                     <a:bodyPr/>
                     <a:lstStyle/>
                     <a:p>
-                      <a:pPr>
-                        <a:defRPr sz="900">
-                          <a:solidFill>
-                            <a:srgbClr val="172852"/>
-                          </a:solidFill>
-                        </a:defRPr>
+                      <a:pPr algn="ctr">
+                        <a:defRPr sz="900" b="0"/>
                       </a:pPr>
                       <a:r>
                         <a:t>4.0%</a:t>
@@ -21278,7 +19273,7 @@
                   </a:txBody>
                   <a:tcPr>
                     <a:solidFill>
-                      <a:srgbClr val="DCEEF4"/>
+                      <a:srgbClr val="F0F8FF"/>
                     </a:solidFill>
                   </a:tcPr>
                 </a:tc>
@@ -21287,12 +19282,8 @@
                     <a:bodyPr/>
                     <a:lstStyle/>
                     <a:p>
-                      <a:pPr>
-                        <a:defRPr sz="900">
-                          <a:solidFill>
-                            <a:srgbClr val="172852"/>
-                          </a:solidFill>
-                        </a:defRPr>
+                      <a:pPr algn="ctr">
+                        <a:defRPr sz="900" b="0"/>
                       </a:pPr>
                       <a:r>
                         <a:t>1.5%</a:t>
@@ -21301,7 +19292,7 @@
                   </a:txBody>
                   <a:tcPr>
                     <a:solidFill>
-                      <a:srgbClr val="DCEEF4"/>
+                      <a:srgbClr val="F0F8FF"/>
                     </a:solidFill>
                   </a:tcPr>
                 </a:tc>
@@ -21310,12 +19301,8 @@
                     <a:bodyPr/>
                     <a:lstStyle/>
                     <a:p>
-                      <a:pPr>
-                        <a:defRPr sz="900">
-                          <a:solidFill>
-                            <a:srgbClr val="172852"/>
-                          </a:solidFill>
-                        </a:defRPr>
+                      <a:pPr algn="ctr">
+                        <a:defRPr sz="900" b="0"/>
                       </a:pPr>
                       <a:r>
                         <a:t>10.0%</a:t>
@@ -21324,7 +19311,7 @@
                   </a:txBody>
                   <a:tcPr>
                     <a:solidFill>
-                      <a:srgbClr val="DCEEF4"/>
+                      <a:srgbClr val="F0F8FF"/>
                     </a:solidFill>
                   </a:tcPr>
                 </a:tc>
@@ -21333,12 +19320,8 @@
                     <a:bodyPr/>
                     <a:lstStyle/>
                     <a:p>
-                      <a:pPr>
-                        <a:defRPr sz="900">
-                          <a:solidFill>
-                            <a:srgbClr val="172852"/>
-                          </a:solidFill>
-                        </a:defRPr>
+                      <a:pPr algn="ctr">
+                        <a:defRPr sz="900" b="0"/>
                       </a:pPr>
                       <a:r>
                         <a:t>5.0%</a:t>
@@ -21347,7 +19330,7 @@
                   </a:txBody>
                   <a:tcPr>
                     <a:solidFill>
-                      <a:srgbClr val="DCEEF4"/>
+                      <a:srgbClr val="F0F8FF"/>
                     </a:solidFill>
                   </a:tcPr>
                 </a:tc>
@@ -21356,12 +19339,8 @@
                     <a:bodyPr/>
                     <a:lstStyle/>
                     <a:p>
-                      <a:pPr>
-                        <a:defRPr sz="900">
-                          <a:solidFill>
-                            <a:srgbClr val="172852"/>
-                          </a:solidFill>
-                        </a:defRPr>
+                      <a:pPr algn="ctr">
+                        <a:defRPr sz="900" b="0"/>
                       </a:pPr>
                       <a:r>
                         <a:t>Submitted</a:t>
@@ -21370,7 +19349,7 @@
                   </a:txBody>
                   <a:tcPr>
                     <a:solidFill>
-                      <a:srgbClr val="DCEEF4"/>
+                      <a:srgbClr val="F0F8FF"/>
                     </a:solidFill>
                   </a:tcPr>
                 </a:tc>
@@ -21411,7 +19390,11 @@
         <p:txBody>
           <a:bodyPr/>
           <a:lstStyle/>
-          <a:p/>
+          <a:p>
+            <a:r>
+              <a:t>Thank You</a:t>
+            </a:r>
+          </a:p>
         </p:txBody>
       </p:sp>
     </p:spTree>

</xml_diff>